<commit_message>
Add QR/link to deck and embed guided tour in Help page
- Deck: add a "Scan to open the app" slide (QR for mlr-app-omega.vercel.app)
  after the sign-in step, and surface the link on the sign-in, closing, and
  quick-facts slides.
- App: serve the walkthrough as public/mlr-app-guide.pdf and add a
  "Take a quick tour" link on the Help page so members can read the
  screen-by-screen onboarding guide in-app.

Co-Authored-By: Claude Opus 4.8 <noreply@anthropic.com>
Claude-Session: https://claude.ai/code/session_01GPsmd6YXd57iQdi83SeC2j
</commit_message>
<xml_diff>
--- a/presentation/MLR-App-Presentation.pptx
+++ b/presentation/MLR-App-Presentation.pptx
@@ -23,6 +23,7 @@
     <p:sldId id="271" r:id="rId23"/>
     <p:sldId id="272" r:id="rId24"/>
     <p:sldId id="273" r:id="rId25"/>
+    <p:sldId id="274" r:id="rId26"/>
   </p:sldIdLst>
   <p:sldSz cx="12191695" cy="6858000" type="screen4x3"/>
   <p:notesSz cx="6858000" cy="9144000"/>
@@ -1009,7 +1010,7 @@
           <a:lstStyle/>
           <a:p>
             <a:r>
-              <a:t>This is the reassurance slide for the older / less techy crowd. Emphasize the human escape hatch — they can always just call you.</a:t>
+              <a:t>Leave this up while people scan. Or read the link aloud: mlr-app-omega.vercel.app. iPhone users: once it opens, add to Home Screen, then sign in there so they don't sign in twice.</a:t>
             </a:r>
           </a:p>
         </p:txBody>
@@ -1079,7 +1080,7 @@
           <a:lstStyle/>
           <a:p>
             <a:r>
-              <a:t>End on action, not features. Get them to do the three things in the room if you can. Then take questions — the appendix has your backup facts.</a:t>
+              <a:t>This is the reassurance slide for the older / less techy crowd. Emphasize the human escape hatch — they can always just call you.</a:t>
             </a:r>
           </a:p>
         </p:txBody>
@@ -1105,6 +1106,76 @@
 </file>
 
 <file path=ppt/notesSlides/notesSlide18.xml><?xml version="1.0" encoding="utf-8"?>
+<p:notes xmlns:a="http://schemas.openxmlformats.org/drawingml/2006/main" xmlns:p="http://schemas.openxmlformats.org/presentationml/2006/main" xmlns:r="http://schemas.openxmlformats.org/officeDocument/2006/relationships">
+  <p:cSld>
+    <p:spTree>
+      <p:nvGrpSpPr>
+        <p:cNvPr id="1" name=""/>
+        <p:cNvGrpSpPr/>
+        <p:nvPr/>
+      </p:nvGrpSpPr>
+      <p:grpSpPr>
+        <a:xfrm>
+          <a:off x="0" y="0"/>
+          <a:ext cx="0" cy="0"/>
+          <a:chOff x="0" y="0"/>
+          <a:chExt cx="0" cy="0"/>
+        </a:xfrm>
+      </p:grpSpPr>
+      <p:sp>
+        <p:nvSpPr>
+          <p:cNvPr id="2" name="Slide Image Placeholder 1"/>
+          <p:cNvSpPr>
+            <a:spLocks noGrp="1"/>
+          </p:cNvSpPr>
+          <p:nvPr>
+            <p:ph type="sldImg" idx="2"/>
+          </p:nvPr>
+        </p:nvSpPr>
+        <p:spPr/>
+      </p:sp>
+      <p:sp>
+        <p:nvSpPr>
+          <p:cNvPr id="3" name="Notes Placeholder 2"/>
+          <p:cNvSpPr>
+            <a:spLocks noGrp="1"/>
+          </p:cNvSpPr>
+          <p:nvPr>
+            <p:ph type="body" idx="3" sz="quarter"/>
+          </p:nvPr>
+        </p:nvSpPr>
+        <p:spPr/>
+        <p:txBody>
+          <a:bodyPr/>
+          <a:lstStyle/>
+          <a:p>
+            <a:r>
+              <a:t>End on action, not features. Get them to do the three things in the room if you can. Then take questions — the appendix has your backup facts.</a:t>
+            </a:r>
+          </a:p>
+        </p:txBody>
+      </p:sp>
+      <p:sp>
+        <p:nvSpPr>
+          <p:cNvPr id="4" name="Slide Number Placeholder 3"/>
+          <p:cNvSpPr>
+            <a:spLocks noGrp="1"/>
+          </p:cNvSpPr>
+          <p:nvPr>
+            <p:ph type="sldNum" idx="5" sz="quarter"/>
+          </p:nvPr>
+        </p:nvSpPr>
+        <p:spPr/>
+      </p:sp>
+    </p:spTree>
+  </p:cSld>
+  <p:clrMapOvr>
+    <a:masterClrMapping/>
+  </p:clrMapOvr>
+</p:notes>
+</file>
+
+<file path=ppt/notesSlides/notesSlide19.xml><?xml version="1.0" encoding="utf-8"?>
 <p:notes xmlns:a="http://schemas.openxmlformats.org/drawingml/2006/main" xmlns:p="http://schemas.openxmlformats.org/presentationml/2006/main" xmlns:r="http://schemas.openxmlformats.org/officeDocument/2006/relationships">
   <p:cSld>
     <p:spTree>
@@ -10769,7 +10840,7 @@
                 </a:solidFill>
                 <a:latin typeface="Calibri"/>
               </a:rPr>
-              <a:t> — (share the URL / QR you have ready)</a:t>
+              <a:t> — go to mlr-app-omega.vercel.app — or scan the code (next slide)</a:t>
             </a:r>
           </a:p>
           <a:p>
@@ -11173,7 +11244,7 @@
                 </a:solidFill>
                 <a:latin typeface="Calibri"/>
               </a:rPr>
-              <a:t>Privacy, safety &amp; help</a:t>
+              <a:t>Scan to open the app</a:t>
             </a:r>
           </a:p>
         </p:txBody>
@@ -11211,7 +11282,7 @@
             <a:avLst/>
           </a:prstGeom>
           <a:solidFill>
-            <a:srgbClr val="F6F6F1"/>
+            <a:srgbClr val="0C4029"/>
           </a:solidFill>
           <a:ln>
             <a:noFill/>
@@ -11242,104 +11313,14 @@
       </p:sp>
       <p:sp>
         <p:nvSpPr>
-          <p:cNvPr id="3" name="Rectangle 2"/>
-          <p:cNvSpPr/>
-          <p:nvPr/>
-        </p:nvSpPr>
-        <p:spPr>
-          <a:xfrm>
-            <a:off x="0" y="0"/>
-            <a:ext cx="12191695" cy="1078992"/>
-          </a:xfrm>
-          <a:prstGeom prst="rect">
-            <a:avLst/>
-          </a:prstGeom>
-          <a:solidFill>
-            <a:srgbClr val="15503A"/>
-          </a:solidFill>
-          <a:ln>
-            <a:noFill/>
-          </a:ln>
-          <a:effectLst/>
-        </p:spPr>
-        <p:style>
-          <a:lnRef idx="1">
-            <a:schemeClr val="accent1"/>
-          </a:lnRef>
-          <a:fillRef idx="3">
-            <a:schemeClr val="accent1"/>
-          </a:fillRef>
-          <a:effectRef idx="2">
-            <a:schemeClr val="accent1"/>
-          </a:effectRef>
-          <a:fontRef idx="minor">
-            <a:schemeClr val="lt1"/>
-          </a:fontRef>
-        </p:style>
-        <p:txBody>
-          <a:bodyPr rtlCol="0" anchor="ctr"/>
-          <a:lstStyle/>
-          <a:p>
-            <a:pPr algn="ctr"/>
-          </a:p>
-        </p:txBody>
-      </p:sp>
-      <p:sp>
-        <p:nvSpPr>
-          <p:cNvPr id="4" name="Rounded Rectangle 3"/>
-          <p:cNvSpPr/>
-          <p:nvPr/>
-        </p:nvSpPr>
-        <p:spPr>
-          <a:xfrm>
-            <a:off x="365760" y="201168"/>
-            <a:ext cx="1371600" cy="676656"/>
-          </a:xfrm>
-          <a:prstGeom prst="roundRect">
-            <a:avLst>
-              <a:gd name="adj" fmla="val 6000"/>
-            </a:avLst>
-          </a:prstGeom>
-          <a:solidFill>
-            <a:srgbClr val="FFFFFF"/>
-          </a:solidFill>
-          <a:ln>
-            <a:noFill/>
-          </a:ln>
-          <a:effectLst/>
-        </p:spPr>
-        <p:style>
-          <a:lnRef idx="1">
-            <a:schemeClr val="accent1"/>
-          </a:lnRef>
-          <a:fillRef idx="3">
-            <a:schemeClr val="accent1"/>
-          </a:fillRef>
-          <a:effectRef idx="2">
-            <a:schemeClr val="accent1"/>
-          </a:effectRef>
-          <a:fontRef idx="minor">
-            <a:schemeClr val="lt1"/>
-          </a:fontRef>
-        </p:style>
-        <p:txBody>
-          <a:bodyPr rtlCol="0" anchor="ctr"/>
-          <a:lstStyle/>
-          <a:p>
-            <a:pPr algn="ctr"/>
-          </a:p>
-        </p:txBody>
-      </p:sp>
-      <p:sp>
-        <p:nvSpPr>
-          <p:cNvPr id="5" name="TextBox 4"/>
+          <p:cNvPr id="3" name="TextBox 2"/>
           <p:cNvSpPr txBox="1"/>
           <p:nvPr/>
         </p:nvSpPr>
         <p:spPr>
           <a:xfrm>
-            <a:off x="365760" y="219456"/>
-            <a:ext cx="1371600" cy="640080"/>
+            <a:off x="640080" y="640080"/>
+            <a:ext cx="10908792" cy="822960"/>
           </a:xfrm>
           <a:prstGeom prst="rect">
             <a:avLst/>
@@ -11347,7 +11328,7 @@
           <a:noFill/>
         </p:spPr>
         <p:txBody>
-          <a:bodyPr wrap="square" anchor="ctr" lIns="25400" rIns="25400" tIns="12700" bIns="12700">
+          <a:bodyPr wrap="square" anchor="t" lIns="25400" rIns="25400" tIns="12700" bIns="12700">
             <a:spAutoFit/>
           </a:bodyPr>
           <a:lstStyle/>
@@ -11364,27 +11345,27 @@
               </a:spcAft>
             </a:pPr>
             <a:r>
-              <a:rPr sz="2200" b="1" i="0">
-                <a:solidFill>
-                  <a:srgbClr val="15503A"/>
-                </a:solidFill>
-                <a:latin typeface="Calibri"/>
-              </a:rPr>
-              <a:t>STEP 15</a:t>
-            </a:r>
-          </a:p>
-        </p:txBody>
-      </p:sp>
-      <p:sp>
-        <p:nvSpPr>
-          <p:cNvPr id="6" name="TextBox 5"/>
+              <a:rPr sz="3600" b="1" i="0">
+                <a:solidFill>
+                  <a:srgbClr val="FFFFFF"/>
+                </a:solidFill>
+                <a:latin typeface="Calibri"/>
+              </a:rPr>
+              <a:t>Scan to open the app</a:t>
+            </a:r>
+          </a:p>
+        </p:txBody>
+      </p:sp>
+      <p:sp>
+        <p:nvSpPr>
+          <p:cNvPr id="4" name="TextBox 3"/>
           <p:cNvSpPr txBox="1"/>
           <p:nvPr/>
         </p:nvSpPr>
         <p:spPr>
           <a:xfrm>
-            <a:off x="1920240" y="146304"/>
-            <a:ext cx="8595360" cy="786384"/>
+            <a:off x="640080" y="1481328"/>
+            <a:ext cx="10908792" cy="457200"/>
           </a:xfrm>
           <a:prstGeom prst="rect">
             <a:avLst/>
@@ -11392,12 +11373,12 @@
           <a:noFill/>
         </p:spPr>
         <p:txBody>
-          <a:bodyPr wrap="square" anchor="ctr" lIns="25400" rIns="25400" tIns="12700" bIns="12700">
+          <a:bodyPr wrap="square" anchor="t" lIns="25400" rIns="25400" tIns="12700" bIns="12700">
             <a:spAutoFit/>
           </a:bodyPr>
           <a:lstStyle/>
           <a:p>
-            <a:pPr algn="l">
+            <a:pPr algn="ctr">
               <a:lnSpc>
                 <a:spcPct val="100000"/>
               </a:lnSpc>
@@ -11409,27 +11390,143 @@
               </a:spcAft>
             </a:pPr>
             <a:r>
-              <a:rPr sz="2700" b="1" i="0">
-                <a:solidFill>
-                  <a:srgbClr val="FFFFFF"/>
-                </a:solidFill>
-                <a:latin typeface="Calibri"/>
-              </a:rPr>
-              <a:t>Privacy, safety &amp; help</a:t>
-            </a:r>
-          </a:p>
-        </p:txBody>
-      </p:sp>
-      <p:sp>
-        <p:nvSpPr>
-          <p:cNvPr id="7" name="TextBox 6"/>
+              <a:rPr sz="1700" b="0" i="0">
+                <a:solidFill>
+                  <a:srgbClr val="E9E2C9"/>
+                </a:solidFill>
+                <a:latin typeface="Calibri"/>
+              </a:rPr>
+              <a:t>Point your phone camera at the code — it opens right up</a:t>
+            </a:r>
+          </a:p>
+        </p:txBody>
+      </p:sp>
+      <p:sp>
+        <p:nvSpPr>
+          <p:cNvPr id="5" name="Rounded Rectangle 4"/>
+          <p:cNvSpPr/>
+          <p:nvPr/>
+        </p:nvSpPr>
+        <p:spPr>
+          <a:xfrm>
+            <a:off x="4358487" y="2057400"/>
+            <a:ext cx="3474720" cy="3474720"/>
+          </a:xfrm>
+          <a:prstGeom prst="roundRect">
+            <a:avLst>
+              <a:gd name="adj" fmla="val 6000"/>
+            </a:avLst>
+          </a:prstGeom>
+          <a:solidFill>
+            <a:srgbClr val="FFFFFF"/>
+          </a:solidFill>
+          <a:ln>
+            <a:noFill/>
+          </a:ln>
+          <a:effectLst/>
+        </p:spPr>
+        <p:style>
+          <a:lnRef idx="1">
+            <a:schemeClr val="accent1"/>
+          </a:lnRef>
+          <a:fillRef idx="3">
+            <a:schemeClr val="accent1"/>
+          </a:fillRef>
+          <a:effectRef idx="2">
+            <a:schemeClr val="accent1"/>
+          </a:effectRef>
+          <a:fontRef idx="minor">
+            <a:schemeClr val="lt1"/>
+          </a:fontRef>
+        </p:style>
+        <p:txBody>
+          <a:bodyPr rtlCol="0" anchor="ctr"/>
+          <a:lstStyle/>
+          <a:p>
+            <a:pPr algn="ctr"/>
+          </a:p>
+        </p:txBody>
+      </p:sp>
+      <p:pic>
+        <p:nvPicPr>
+          <p:cNvPr id="6" name="Picture 5" descr="qr_app.png"/>
+          <p:cNvPicPr>
+            <a:picLocks noChangeAspect="1"/>
+          </p:cNvPicPr>
+          <p:nvPr/>
+        </p:nvPicPr>
+        <p:blipFill>
+          <a:blip r:embed="rId2"/>
+          <a:stretch>
+            <a:fillRect/>
+          </a:stretch>
+        </p:blipFill>
+        <p:spPr>
+          <a:xfrm>
+            <a:off x="4587087" y="2286000"/>
+            <a:ext cx="3017520" cy="3017520"/>
+          </a:xfrm>
+          <a:prstGeom prst="rect">
+            <a:avLst/>
+          </a:prstGeom>
+        </p:spPr>
+      </p:pic>
+      <p:sp>
+        <p:nvSpPr>
+          <p:cNvPr id="7" name="Rounded Rectangle 6"/>
+          <p:cNvSpPr/>
+          <p:nvPr/>
+        </p:nvSpPr>
+        <p:spPr>
+          <a:xfrm>
+            <a:off x="3261207" y="5806440"/>
+            <a:ext cx="5669280" cy="566928"/>
+          </a:xfrm>
+          <a:prstGeom prst="roundRect">
+            <a:avLst>
+              <a:gd name="adj" fmla="val 6000"/>
+            </a:avLst>
+          </a:prstGeom>
+          <a:solidFill>
+            <a:srgbClr val="C2410C"/>
+          </a:solidFill>
+          <a:ln>
+            <a:noFill/>
+          </a:ln>
+          <a:effectLst/>
+        </p:spPr>
+        <p:style>
+          <a:lnRef idx="1">
+            <a:schemeClr val="accent1"/>
+          </a:lnRef>
+          <a:fillRef idx="3">
+            <a:schemeClr val="accent1"/>
+          </a:fillRef>
+          <a:effectRef idx="2">
+            <a:schemeClr val="accent1"/>
+          </a:effectRef>
+          <a:fontRef idx="minor">
+            <a:schemeClr val="lt1"/>
+          </a:fontRef>
+        </p:style>
+        <p:txBody>
+          <a:bodyPr rtlCol="0" anchor="ctr"/>
+          <a:lstStyle/>
+          <a:p>
+            <a:pPr algn="ctr"/>
+          </a:p>
+        </p:txBody>
+      </p:sp>
+      <p:sp>
+        <p:nvSpPr>
+          <p:cNvPr id="8" name="TextBox 7"/>
           <p:cNvSpPr txBox="1"/>
           <p:nvPr/>
         </p:nvSpPr>
         <p:spPr>
           <a:xfrm>
-            <a:off x="9509760" y="146304"/>
-            <a:ext cx="2377440" cy="786384"/>
+            <a:off x="3261207" y="5824728"/>
+            <a:ext cx="5669280" cy="530352"/>
           </a:xfrm>
           <a:prstGeom prst="rect">
             <a:avLst/>
@@ -11442,7 +11539,7 @@
           </a:bodyPr>
           <a:lstStyle/>
           <a:p>
-            <a:pPr algn="r">
+            <a:pPr algn="ctr">
               <a:lnSpc>
                 <a:spcPct val="100000"/>
               </a:lnSpc>
@@ -11454,755 +11551,13 @@
               </a:spcAft>
             </a:pPr>
             <a:r>
-              <a:rPr sz="1300" b="0" i="0">
-                <a:solidFill>
-                  <a:srgbClr val="ECF3EF"/>
-                </a:solidFill>
-                <a:latin typeface="Calibri"/>
-              </a:rPr>
-              <a:t>Step 15 of 16</a:t>
-            </a:r>
-          </a:p>
-        </p:txBody>
-      </p:sp>
-      <p:sp>
-        <p:nvSpPr>
-          <p:cNvPr id="8" name="Rounded Rectangle 7"/>
-          <p:cNvSpPr/>
-          <p:nvPr/>
-        </p:nvSpPr>
-        <p:spPr>
-          <a:xfrm>
-            <a:off x="502920" y="1298448"/>
-            <a:ext cx="11201400" cy="603504"/>
-          </a:xfrm>
-          <a:prstGeom prst="roundRect">
-            <a:avLst>
-              <a:gd name="adj" fmla="val 6000"/>
-            </a:avLst>
-          </a:prstGeom>
-          <a:solidFill>
-            <a:srgbClr val="ECF3EF"/>
-          </a:solidFill>
-          <a:ln w="12700">
-            <a:solidFill>
-              <a:srgbClr val="E5E4DA"/>
-            </a:solidFill>
-          </a:ln>
-          <a:effectLst/>
-        </p:spPr>
-        <p:style>
-          <a:lnRef idx="1">
-            <a:schemeClr val="accent1"/>
-          </a:lnRef>
-          <a:fillRef idx="3">
-            <a:schemeClr val="accent1"/>
-          </a:fillRef>
-          <a:effectRef idx="2">
-            <a:schemeClr val="accent1"/>
-          </a:effectRef>
-          <a:fontRef idx="minor">
-            <a:schemeClr val="lt1"/>
-          </a:fontRef>
-        </p:style>
-        <p:txBody>
-          <a:bodyPr rtlCol="0" anchor="ctr"/>
-          <a:lstStyle/>
-          <a:p>
-            <a:pPr algn="ctr"/>
-          </a:p>
-        </p:txBody>
-      </p:sp>
-      <p:sp>
-        <p:nvSpPr>
-          <p:cNvPr id="9" name="TextBox 8"/>
-          <p:cNvSpPr txBox="1"/>
-          <p:nvPr/>
-        </p:nvSpPr>
-        <p:spPr>
-          <a:xfrm>
-            <a:off x="667512" y="1298448"/>
-            <a:ext cx="1463040" cy="603504"/>
-          </a:xfrm>
-          <a:prstGeom prst="rect">
-            <a:avLst/>
-          </a:prstGeom>
-          <a:noFill/>
-        </p:spPr>
-        <p:txBody>
-          <a:bodyPr wrap="square" anchor="ctr" lIns="25400" rIns="25400" tIns="12700" bIns="12700">
-            <a:spAutoFit/>
-          </a:bodyPr>
-          <a:lstStyle/>
-          <a:p>
-            <a:pPr algn="l">
-              <a:lnSpc>
-                <a:spcPct val="100000"/>
-              </a:lnSpc>
-              <a:spcBef>
-                <a:spcPts val="0"/>
-              </a:spcBef>
-              <a:spcAft>
-                <a:spcPts val="400"/>
-              </a:spcAft>
-            </a:pPr>
-            <a:r>
-              <a:rPr sz="1300" b="1" i="0">
-                <a:solidFill>
-                  <a:srgbClr val="15503A"/>
-                </a:solidFill>
-                <a:latin typeface="Calibri"/>
-              </a:rPr>
-              <a:t>📍  FIND IT</a:t>
-            </a:r>
-          </a:p>
-        </p:txBody>
-      </p:sp>
-      <p:sp>
-        <p:nvSpPr>
-          <p:cNvPr id="10" name="TextBox 9"/>
-          <p:cNvSpPr txBox="1"/>
-          <p:nvPr/>
-        </p:nvSpPr>
-        <p:spPr>
-          <a:xfrm>
-            <a:off x="2194560" y="1298448"/>
-            <a:ext cx="9372600" cy="603504"/>
-          </a:xfrm>
-          <a:prstGeom prst="rect">
-            <a:avLst/>
-          </a:prstGeom>
-          <a:noFill/>
-        </p:spPr>
-        <p:txBody>
-          <a:bodyPr wrap="square" anchor="ctr" lIns="25400" rIns="25400" tIns="12700" bIns="12700">
-            <a:spAutoFit/>
-          </a:bodyPr>
-          <a:lstStyle/>
-          <a:p>
-            <a:pPr algn="l">
-              <a:lnSpc>
-                <a:spcPct val="100000"/>
-              </a:lnSpc>
-              <a:spcBef>
-                <a:spcPts val="0"/>
-              </a:spcBef>
-              <a:spcAft>
-                <a:spcPts val="400"/>
-              </a:spcAft>
-            </a:pPr>
-            <a:r>
-              <a:rPr sz="1500" b="1" i="0">
-                <a:solidFill>
-                  <a:srgbClr val="14241C"/>
-                </a:solidFill>
-                <a:latin typeface="Calibri"/>
-              </a:rPr>
-              <a:t>Profile  →  Text size  ·  Help page</a:t>
-            </a:r>
-          </a:p>
-        </p:txBody>
-      </p:sp>
-      <p:sp>
-        <p:nvSpPr>
-          <p:cNvPr id="11" name="Rounded Rectangle 10"/>
-          <p:cNvSpPr/>
-          <p:nvPr/>
-        </p:nvSpPr>
-        <p:spPr>
-          <a:xfrm>
-            <a:off x="502920" y="2029968"/>
-            <a:ext cx="11201400" cy="786384"/>
-          </a:xfrm>
-          <a:prstGeom prst="roundRect">
-            <a:avLst>
-              <a:gd name="adj" fmla="val 6000"/>
-            </a:avLst>
-          </a:prstGeom>
-          <a:solidFill>
-            <a:srgbClr val="FBF7EC"/>
-          </a:solidFill>
-          <a:ln w="12700">
-            <a:solidFill>
-              <a:srgbClr val="E6D9B8"/>
-            </a:solidFill>
-          </a:ln>
-          <a:effectLst/>
-        </p:spPr>
-        <p:style>
-          <a:lnRef idx="1">
-            <a:schemeClr val="accent1"/>
-          </a:lnRef>
-          <a:fillRef idx="3">
-            <a:schemeClr val="accent1"/>
-          </a:fillRef>
-          <a:effectRef idx="2">
-            <a:schemeClr val="accent1"/>
-          </a:effectRef>
-          <a:fontRef idx="minor">
-            <a:schemeClr val="lt1"/>
-          </a:fontRef>
-        </p:style>
-        <p:txBody>
-          <a:bodyPr rtlCol="0" anchor="ctr"/>
-          <a:lstStyle/>
-          <a:p>
-            <a:pPr algn="ctr"/>
-          </a:p>
-        </p:txBody>
-      </p:sp>
-      <p:sp>
-        <p:nvSpPr>
-          <p:cNvPr id="12" name="Rectangle 11"/>
-          <p:cNvSpPr/>
-          <p:nvPr/>
-        </p:nvSpPr>
-        <p:spPr>
-          <a:xfrm>
-            <a:off x="502920" y="2029968"/>
-            <a:ext cx="91440" cy="786384"/>
-          </a:xfrm>
-          <a:prstGeom prst="rect">
-            <a:avLst/>
-          </a:prstGeom>
-          <a:solidFill>
-            <a:srgbClr val="C2410C"/>
-          </a:solidFill>
-          <a:ln>
-            <a:noFill/>
-          </a:ln>
-          <a:effectLst/>
-        </p:spPr>
-        <p:style>
-          <a:lnRef idx="1">
-            <a:schemeClr val="accent1"/>
-          </a:lnRef>
-          <a:fillRef idx="3">
-            <a:schemeClr val="accent1"/>
-          </a:fillRef>
-          <a:effectRef idx="2">
-            <a:schemeClr val="accent1"/>
-          </a:effectRef>
-          <a:fontRef idx="minor">
-            <a:schemeClr val="lt1"/>
-          </a:fontRef>
-        </p:style>
-        <p:txBody>
-          <a:bodyPr rtlCol="0" anchor="ctr"/>
-          <a:lstStyle/>
-          <a:p>
-            <a:pPr algn="ctr"/>
-          </a:p>
-        </p:txBody>
-      </p:sp>
-      <p:sp>
-        <p:nvSpPr>
-          <p:cNvPr id="13" name="TextBox 12"/>
-          <p:cNvSpPr txBox="1"/>
-          <p:nvPr/>
-        </p:nvSpPr>
-        <p:spPr>
-          <a:xfrm>
-            <a:off x="813816" y="2029968"/>
-            <a:ext cx="10698480" cy="786384"/>
-          </a:xfrm>
-          <a:prstGeom prst="rect">
-            <a:avLst/>
-          </a:prstGeom>
-          <a:noFill/>
-        </p:spPr>
-        <p:txBody>
-          <a:bodyPr wrap="square" anchor="ctr" lIns="25400" rIns="25400" tIns="12700" bIns="12700">
-            <a:spAutoFit/>
-          </a:bodyPr>
-          <a:lstStyle/>
-          <a:p>
-            <a:pPr algn="l">
-              <a:lnSpc>
-                <a:spcPct val="100000"/>
-              </a:lnSpc>
-              <a:spcBef>
-                <a:spcPts val="0"/>
-              </a:spcBef>
-              <a:spcAft>
-                <a:spcPts val="400"/>
-              </a:spcAft>
-            </a:pPr>
-            <a:r>
-              <a:rPr sz="1800" b="1" i="0">
-                <a:solidFill>
-                  <a:srgbClr val="14241C"/>
-                </a:solidFill>
-                <a:latin typeface="Calibri"/>
-              </a:rPr>
-              <a:t>It's just us — family only — and we made it easy for every age to use.</a:t>
-            </a:r>
-          </a:p>
-        </p:txBody>
-      </p:sp>
-      <p:sp>
-        <p:nvSpPr>
-          <p:cNvPr id="14" name="TextBox 13"/>
-          <p:cNvSpPr txBox="1"/>
-          <p:nvPr/>
-        </p:nvSpPr>
-        <p:spPr>
-          <a:xfrm>
-            <a:off x="594360" y="3035808"/>
-            <a:ext cx="11018520" cy="2468880"/>
-          </a:xfrm>
-          <a:prstGeom prst="rect">
-            <a:avLst/>
-          </a:prstGeom>
-          <a:noFill/>
-        </p:spPr>
-        <p:txBody>
-          <a:bodyPr wrap="square" anchor="t" lIns="25400" rIns="25400" tIns="12700" bIns="12700">
-            <a:spAutoFit/>
-          </a:bodyPr>
-          <a:lstStyle/>
-          <a:p>
-            <a:pPr algn="l">
-              <a:lnSpc>
-                <a:spcPct val="100000"/>
-              </a:lnSpc>
-              <a:spcBef>
-                <a:spcPts val="0"/>
-              </a:spcBef>
-              <a:spcAft>
-                <a:spcPts val="1000"/>
-              </a:spcAft>
-            </a:pPr>
-            <a:r>
-              <a:rPr sz="1600" b="1" i="0">
-                <a:solidFill>
-                  <a:srgbClr val="15503A"/>
-                </a:solidFill>
-                <a:latin typeface="Calibri"/>
-              </a:rPr>
-              <a:t>•  </a:t>
-            </a:r>
-            <a:r>
-              <a:rPr sz="1600" b="1" i="0">
-                <a:solidFill>
-                  <a:srgbClr val="14241C"/>
-                </a:solidFill>
-                <a:latin typeface="Calibri"/>
-              </a:rPr>
-              <a:t>Family only</a:t>
-            </a:r>
-            <a:r>
-              <a:rPr sz="1600" b="0" i="0">
-                <a:solidFill>
-                  <a:srgbClr val="14241C"/>
-                </a:solidFill>
-                <a:latin typeface="Calibri"/>
-              </a:rPr>
-              <a:t> — not public; sensitive info hidden until you sign in</a:t>
-            </a:r>
-          </a:p>
-          <a:p>
-            <a:pPr algn="l">
-              <a:lnSpc>
-                <a:spcPct val="100000"/>
-              </a:lnSpc>
-              <a:spcBef>
-                <a:spcPts val="0"/>
-              </a:spcBef>
-              <a:spcAft>
-                <a:spcPts val="1000"/>
-              </a:spcAft>
-            </a:pPr>
-            <a:r>
-              <a:rPr sz="1600" b="1" i="0">
-                <a:solidFill>
-                  <a:srgbClr val="15503A"/>
-                </a:solidFill>
-                <a:latin typeface="Calibri"/>
-              </a:rPr>
-              <a:t>•  </a:t>
-            </a:r>
-            <a:r>
-              <a:rPr sz="1600" b="1" i="0">
-                <a:solidFill>
-                  <a:srgbClr val="14241C"/>
-                </a:solidFill>
-                <a:latin typeface="Calibri"/>
-              </a:rPr>
-              <a:t>Bigger text</a:t>
-            </a:r>
-            <a:r>
-              <a:rPr sz="1600" b="0" i="0">
-                <a:solidFill>
-                  <a:srgbClr val="14241C"/>
-                </a:solidFill>
-                <a:latin typeface="Calibri"/>
-              </a:rPr>
-              <a:t> — Profile → Text size: Normal / Large / Largest</a:t>
-            </a:r>
-          </a:p>
-          <a:p>
-            <a:pPr algn="l">
-              <a:lnSpc>
-                <a:spcPct val="100000"/>
-              </a:lnSpc>
-              <a:spcBef>
-                <a:spcPts val="0"/>
-              </a:spcBef>
-              <a:spcAft>
-                <a:spcPts val="1000"/>
-              </a:spcAft>
-            </a:pPr>
-            <a:r>
-              <a:rPr sz="1600" b="1" i="0">
-                <a:solidFill>
-                  <a:srgbClr val="15503A"/>
-                </a:solidFill>
-                <a:latin typeface="Calibri"/>
-              </a:rPr>
-              <a:t>•  </a:t>
-            </a:r>
-            <a:r>
-              <a:rPr sz="1600" b="1" i="0">
-                <a:solidFill>
-                  <a:srgbClr val="14241C"/>
-                </a:solidFill>
-                <a:latin typeface="Calibri"/>
-              </a:rPr>
-              <a:t>Help page</a:t>
-            </a:r>
-            <a:r>
-              <a:rPr sz="1600" b="0" i="0">
-                <a:solidFill>
-                  <a:srgbClr val="14241C"/>
-                </a:solidFill>
-                <a:latin typeface="Calibri"/>
-              </a:rPr>
-              <a:t> — plain-language how-tos for anyone stuck</a:t>
-            </a:r>
-          </a:p>
-          <a:p>
-            <a:pPr algn="l">
-              <a:lnSpc>
-                <a:spcPct val="100000"/>
-              </a:lnSpc>
-              <a:spcBef>
-                <a:spcPts val="0"/>
-              </a:spcBef>
-              <a:spcAft>
-                <a:spcPts val="1000"/>
-              </a:spcAft>
-            </a:pPr>
-            <a:r>
-              <a:rPr sz="1600" b="1" i="0">
-                <a:solidFill>
-                  <a:srgbClr val="15503A"/>
-                </a:solidFill>
-                <a:latin typeface="Calibri"/>
-              </a:rPr>
-              <a:t>•  </a:t>
-            </a:r>
-            <a:r>
-              <a:rPr sz="1600" b="1" i="0">
-                <a:solidFill>
-                  <a:srgbClr val="14241C"/>
-                </a:solidFill>
-                <a:latin typeface="Calibri"/>
-              </a:rPr>
-              <a:t>A real person</a:t>
-            </a:r>
-            <a:r>
-              <a:rPr sz="1600" b="0" i="0">
-                <a:solidFill>
-                  <a:srgbClr val="14241C"/>
-                </a:solidFill>
-                <a:latin typeface="Calibri"/>
-              </a:rPr>
-              <a:t> — text or call me (Brian) anytime — it's on the Help page</a:t>
-            </a:r>
-          </a:p>
-        </p:txBody>
-      </p:sp>
-      <p:sp>
-        <p:nvSpPr>
-          <p:cNvPr id="15" name="Rounded Rectangle 14"/>
-          <p:cNvSpPr/>
-          <p:nvPr/>
-        </p:nvSpPr>
-        <p:spPr>
-          <a:xfrm>
-            <a:off x="502920" y="5486400"/>
-            <a:ext cx="11201400" cy="566928"/>
-          </a:xfrm>
-          <a:prstGeom prst="roundRect">
-            <a:avLst>
-              <a:gd name="adj" fmla="val 6000"/>
-            </a:avLst>
-          </a:prstGeom>
-          <a:solidFill>
-            <a:srgbClr val="F3EEF0"/>
-          </a:solidFill>
-          <a:ln w="12700">
-            <a:solidFill>
-              <a:srgbClr val="E5E4DA"/>
-            </a:solidFill>
-          </a:ln>
-          <a:effectLst/>
-        </p:spPr>
-        <p:style>
-          <a:lnRef idx="1">
-            <a:schemeClr val="accent1"/>
-          </a:lnRef>
-          <a:fillRef idx="3">
-            <a:schemeClr val="accent1"/>
-          </a:fillRef>
-          <a:effectRef idx="2">
-            <a:schemeClr val="accent1"/>
-          </a:effectRef>
-          <a:fontRef idx="minor">
-            <a:schemeClr val="lt1"/>
-          </a:fontRef>
-        </p:style>
-        <p:txBody>
-          <a:bodyPr rtlCol="0" anchor="ctr"/>
-          <a:lstStyle/>
-          <a:p>
-            <a:pPr algn="ctr"/>
-          </a:p>
-        </p:txBody>
-      </p:sp>
-      <p:sp>
-        <p:nvSpPr>
-          <p:cNvPr id="16" name="TextBox 15"/>
-          <p:cNvSpPr txBox="1"/>
-          <p:nvPr/>
-        </p:nvSpPr>
-        <p:spPr>
-          <a:xfrm>
-            <a:off x="667512" y="5486400"/>
-            <a:ext cx="1828800" cy="566928"/>
-          </a:xfrm>
-          <a:prstGeom prst="rect">
-            <a:avLst/>
-          </a:prstGeom>
-          <a:noFill/>
-        </p:spPr>
-        <p:txBody>
-          <a:bodyPr wrap="square" anchor="ctr" lIns="25400" rIns="25400" tIns="12700" bIns="12700">
-            <a:spAutoFit/>
-          </a:bodyPr>
-          <a:lstStyle/>
-          <a:p>
-            <a:pPr algn="l">
-              <a:lnSpc>
-                <a:spcPct val="100000"/>
-              </a:lnSpc>
-              <a:spcBef>
-                <a:spcPts val="0"/>
-              </a:spcBef>
-              <a:spcAft>
-                <a:spcPts val="400"/>
-              </a:spcAft>
-            </a:pPr>
-            <a:r>
-              <a:rPr sz="1200" b="1" i="0">
-                <a:solidFill>
-                  <a:srgbClr val="8B2E2E"/>
-                </a:solidFill>
-                <a:latin typeface="Calibri"/>
-              </a:rPr>
-              <a:t>💡 GOOD TO KNOW</a:t>
-            </a:r>
-          </a:p>
-        </p:txBody>
-      </p:sp>
-      <p:sp>
-        <p:nvSpPr>
-          <p:cNvPr id="17" name="TextBox 16"/>
-          <p:cNvSpPr txBox="1"/>
-          <p:nvPr/>
-        </p:nvSpPr>
-        <p:spPr>
-          <a:xfrm>
-            <a:off x="2560320" y="5486400"/>
-            <a:ext cx="9006840" cy="566928"/>
-          </a:xfrm>
-          <a:prstGeom prst="rect">
-            <a:avLst/>
-          </a:prstGeom>
-          <a:noFill/>
-        </p:spPr>
-        <p:txBody>
-          <a:bodyPr wrap="square" anchor="ctr" lIns="25400" rIns="25400" tIns="12700" bIns="12700">
-            <a:spAutoFit/>
-          </a:bodyPr>
-          <a:lstStyle/>
-          <a:p>
-            <a:pPr algn="l">
-              <a:lnSpc>
-                <a:spcPct val="100000"/>
-              </a:lnSpc>
-              <a:spcBef>
-                <a:spcPts val="0"/>
-              </a:spcBef>
-              <a:spcAft>
-                <a:spcPts val="400"/>
-              </a:spcAft>
-            </a:pPr>
-            <a:r>
-              <a:rPr sz="1300" b="0" i="0">
-                <a:solidFill>
-                  <a:srgbClr val="14241C"/>
-                </a:solidFill>
-                <a:latin typeface="Calibri"/>
-              </a:rPr>
-              <a:t>“No strangers, no ads, no selling anything. It's our family's app.”</a:t>
-            </a:r>
-          </a:p>
-        </p:txBody>
-      </p:sp>
-      <p:sp>
-        <p:nvSpPr>
-          <p:cNvPr id="18" name="Rounded Rectangle 17"/>
-          <p:cNvSpPr/>
-          <p:nvPr/>
-        </p:nvSpPr>
-        <p:spPr>
-          <a:xfrm>
-            <a:off x="365760" y="6510528"/>
-            <a:ext cx="11521440" cy="63500"/>
-          </a:xfrm>
-          <a:prstGeom prst="roundRect">
-            <a:avLst>
-              <a:gd name="adj" fmla="val 6000"/>
-            </a:avLst>
-          </a:prstGeom>
-          <a:solidFill>
-            <a:srgbClr val="E5E4DA"/>
-          </a:solidFill>
-          <a:ln>
-            <a:noFill/>
-          </a:ln>
-          <a:effectLst/>
-        </p:spPr>
-        <p:style>
-          <a:lnRef idx="1">
-            <a:schemeClr val="accent1"/>
-          </a:lnRef>
-          <a:fillRef idx="3">
-            <a:schemeClr val="accent1"/>
-          </a:fillRef>
-          <a:effectRef idx="2">
-            <a:schemeClr val="accent1"/>
-          </a:effectRef>
-          <a:fontRef idx="minor">
-            <a:schemeClr val="lt1"/>
-          </a:fontRef>
-        </p:style>
-        <p:txBody>
-          <a:bodyPr rtlCol="0" anchor="ctr"/>
-          <a:lstStyle/>
-          <a:p>
-            <a:pPr algn="ctr"/>
-          </a:p>
-        </p:txBody>
-      </p:sp>
-      <p:sp>
-        <p:nvSpPr>
-          <p:cNvPr id="19" name="Rounded Rectangle 18"/>
-          <p:cNvSpPr/>
-          <p:nvPr/>
-        </p:nvSpPr>
-        <p:spPr>
-          <a:xfrm>
-            <a:off x="365760" y="6510528"/>
-            <a:ext cx="10801350" cy="63500"/>
-          </a:xfrm>
-          <a:prstGeom prst="roundRect">
-            <a:avLst>
-              <a:gd name="adj" fmla="val 6000"/>
-            </a:avLst>
-          </a:prstGeom>
-          <a:solidFill>
-            <a:srgbClr val="15503A"/>
-          </a:solidFill>
-          <a:ln>
-            <a:noFill/>
-          </a:ln>
-          <a:effectLst/>
-        </p:spPr>
-        <p:style>
-          <a:lnRef idx="1">
-            <a:schemeClr val="accent1"/>
-          </a:lnRef>
-          <a:fillRef idx="3">
-            <a:schemeClr val="accent1"/>
-          </a:fillRef>
-          <a:effectRef idx="2">
-            <a:schemeClr val="accent1"/>
-          </a:effectRef>
-          <a:fontRef idx="minor">
-            <a:schemeClr val="lt1"/>
-          </a:fontRef>
-        </p:style>
-        <p:txBody>
-          <a:bodyPr rtlCol="0" anchor="ctr"/>
-          <a:lstStyle/>
-          <a:p>
-            <a:pPr algn="ctr"/>
-          </a:p>
-        </p:txBody>
-      </p:sp>
-      <p:sp>
-        <p:nvSpPr>
-          <p:cNvPr id="20" name="TextBox 19"/>
-          <p:cNvSpPr txBox="1"/>
-          <p:nvPr/>
-        </p:nvSpPr>
-        <p:spPr>
-          <a:xfrm>
-            <a:off x="365760" y="6163056"/>
-            <a:ext cx="11430000" cy="292608"/>
-          </a:xfrm>
-          <a:prstGeom prst="rect">
-            <a:avLst/>
-          </a:prstGeom>
-          <a:noFill/>
-        </p:spPr>
-        <p:txBody>
-          <a:bodyPr wrap="square" anchor="t" lIns="25400" rIns="25400" tIns="12700" bIns="12700">
-            <a:spAutoFit/>
-          </a:bodyPr>
-          <a:lstStyle/>
-          <a:p>
-            <a:pPr algn="l">
-              <a:lnSpc>
-                <a:spcPct val="100000"/>
-              </a:lnSpc>
-              <a:spcBef>
-                <a:spcPts val="0"/>
-              </a:spcBef>
-              <a:spcAft>
-                <a:spcPts val="400"/>
-              </a:spcAft>
-            </a:pPr>
-            <a:r>
-              <a:rPr sz="1100" b="1" i="0">
-                <a:solidFill>
-                  <a:srgbClr val="6B7068"/>
-                </a:solidFill>
-                <a:latin typeface="Calibri"/>
-              </a:rPr>
-              <a:t>NEXT  ›  </a:t>
-            </a:r>
-            <a:r>
-              <a:rPr sz="1100" b="0" i="1">
-                <a:solidFill>
-                  <a:srgbClr val="6B7068"/>
-                </a:solidFill>
-                <a:latin typeface="Calibri"/>
-              </a:rPr>
-              <a:t>What to do right now</a:t>
+              <a:rPr sz="2000" b="1" i="0">
+                <a:solidFill>
+                  <a:srgbClr val="FFFFFF"/>
+                </a:solidFill>
+                <a:latin typeface="Calibri"/>
+              </a:rPr>
+              <a:t>mlr-app-omega.vercel.app</a:t>
             </a:r>
           </a:p>
         </p:txBody>
@@ -12284,7 +11639,7 @@
             <a:avLst/>
           </a:prstGeom>
           <a:solidFill>
-            <a:srgbClr val="C2410C"/>
+            <a:srgbClr val="15503A"/>
           </a:solidFill>
           <a:ln>
             <a:noFill/>
@@ -12395,11 +11750,11 @@
             <a:r>
               <a:rPr sz="2200" b="1" i="0">
                 <a:solidFill>
-                  <a:srgbClr val="C2410C"/>
-                </a:solidFill>
-                <a:latin typeface="Calibri"/>
-              </a:rPr>
-              <a:t>STEP 16</a:t>
+                  <a:srgbClr val="15503A"/>
+                </a:solidFill>
+                <a:latin typeface="Calibri"/>
+              </a:rPr>
+              <a:t>STEP 15</a:t>
             </a:r>
           </a:p>
         </p:txBody>
@@ -12444,7 +11799,7 @@
                 </a:solidFill>
                 <a:latin typeface="Calibri"/>
               </a:rPr>
-              <a:t>BEFORE YOU LEAVE</a:t>
+              <a:t>Privacy, safety &amp; help</a:t>
             </a:r>
           </a:p>
         </p:txBody>
@@ -12489,21 +11844,69 @@
                 </a:solidFill>
                 <a:latin typeface="Calibri"/>
               </a:rPr>
-              <a:t>Step 16 of 16</a:t>
-            </a:r>
-          </a:p>
-        </p:txBody>
-      </p:sp>
-      <p:sp>
-        <p:nvSpPr>
-          <p:cNvPr id="8" name="TextBox 7"/>
+              <a:t>Step 15 of 16</a:t>
+            </a:r>
+          </a:p>
+        </p:txBody>
+      </p:sp>
+      <p:sp>
+        <p:nvSpPr>
+          <p:cNvPr id="8" name="Rounded Rectangle 7"/>
+          <p:cNvSpPr/>
+          <p:nvPr/>
+        </p:nvSpPr>
+        <p:spPr>
+          <a:xfrm>
+            <a:off x="502920" y="1298448"/>
+            <a:ext cx="11201400" cy="603504"/>
+          </a:xfrm>
+          <a:prstGeom prst="roundRect">
+            <a:avLst>
+              <a:gd name="adj" fmla="val 6000"/>
+            </a:avLst>
+          </a:prstGeom>
+          <a:solidFill>
+            <a:srgbClr val="ECF3EF"/>
+          </a:solidFill>
+          <a:ln w="12700">
+            <a:solidFill>
+              <a:srgbClr val="E5E4DA"/>
+            </a:solidFill>
+          </a:ln>
+          <a:effectLst/>
+        </p:spPr>
+        <p:style>
+          <a:lnRef idx="1">
+            <a:schemeClr val="accent1"/>
+          </a:lnRef>
+          <a:fillRef idx="3">
+            <a:schemeClr val="accent1"/>
+          </a:fillRef>
+          <a:effectRef idx="2">
+            <a:schemeClr val="accent1"/>
+          </a:effectRef>
+          <a:fontRef idx="minor">
+            <a:schemeClr val="lt1"/>
+          </a:fontRef>
+        </p:style>
+        <p:txBody>
+          <a:bodyPr rtlCol="0" anchor="ctr"/>
+          <a:lstStyle/>
+          <a:p>
+            <a:pPr algn="ctr"/>
+          </a:p>
+        </p:txBody>
+      </p:sp>
+      <p:sp>
+        <p:nvSpPr>
+          <p:cNvPr id="9" name="TextBox 8"/>
           <p:cNvSpPr txBox="1"/>
           <p:nvPr/>
         </p:nvSpPr>
         <p:spPr>
           <a:xfrm>
-            <a:off x="640080" y="1371600"/>
-            <a:ext cx="10972800" cy="914400"/>
+            <a:off x="667512" y="1298448"/>
+            <a:ext cx="1463040" cy="603504"/>
           </a:xfrm>
           <a:prstGeom prst="rect">
             <a:avLst/>
@@ -12511,7 +11914,7 @@
           <a:noFill/>
         </p:spPr>
         <p:txBody>
-          <a:bodyPr wrap="square" anchor="t" lIns="25400" rIns="25400" tIns="12700" bIns="12700">
+          <a:bodyPr wrap="square" anchor="ctr" lIns="25400" rIns="25400" tIns="12700" bIns="12700">
             <a:spAutoFit/>
           </a:bodyPr>
           <a:lstStyle/>
@@ -12528,62 +11931,14 @@
               </a:spcAft>
             </a:pPr>
             <a:r>
-              <a:rPr sz="3200" b="1" i="0">
-                <a:solidFill>
-                  <a:srgbClr val="14241C"/>
-                </a:solidFill>
-                <a:latin typeface="Calibri"/>
-              </a:rPr>
-              <a:t>Three things to do right now</a:t>
-            </a:r>
-          </a:p>
-        </p:txBody>
-      </p:sp>
-      <p:sp>
-        <p:nvSpPr>
-          <p:cNvPr id="9" name="Rounded Rectangle 8"/>
-          <p:cNvSpPr/>
-          <p:nvPr/>
-        </p:nvSpPr>
-        <p:spPr>
-          <a:xfrm>
-            <a:off x="640080" y="2331720"/>
-            <a:ext cx="10908792" cy="3566160"/>
-          </a:xfrm>
-          <a:prstGeom prst="roundRect">
-            <a:avLst>
-              <a:gd name="adj" fmla="val 6000"/>
-            </a:avLst>
-          </a:prstGeom>
-          <a:solidFill>
-            <a:srgbClr val="FFFFFF"/>
-          </a:solidFill>
-          <a:ln w="12700">
-            <a:solidFill>
-              <a:srgbClr val="E5E4DA"/>
-            </a:solidFill>
-          </a:ln>
-          <a:effectLst/>
-        </p:spPr>
-        <p:style>
-          <a:lnRef idx="1">
-            <a:schemeClr val="accent1"/>
-          </a:lnRef>
-          <a:fillRef idx="3">
-            <a:schemeClr val="accent1"/>
-          </a:fillRef>
-          <a:effectRef idx="2">
-            <a:schemeClr val="accent1"/>
-          </a:effectRef>
-          <a:fontRef idx="minor">
-            <a:schemeClr val="lt1"/>
-          </a:fontRef>
-        </p:style>
-        <p:txBody>
-          <a:bodyPr rtlCol="0" anchor="ctr"/>
-          <a:lstStyle/>
-          <a:p>
-            <a:pPr algn="ctr"/>
+              <a:rPr sz="1300" b="1" i="0">
+                <a:solidFill>
+                  <a:srgbClr val="15503A"/>
+                </a:solidFill>
+                <a:latin typeface="Calibri"/>
+              </a:rPr>
+              <a:t>📍  FIND IT</a:t>
+            </a:r>
           </a:p>
         </p:txBody>
       </p:sp>
@@ -12595,8 +11950,8 @@
         </p:nvSpPr>
         <p:spPr>
           <a:xfrm>
-            <a:off x="1005840" y="2606040"/>
-            <a:ext cx="10149840" cy="3108960"/>
+            <a:off x="2194560" y="1298448"/>
+            <a:ext cx="9372600" cy="603504"/>
           </a:xfrm>
           <a:prstGeom prst="rect">
             <a:avLst/>
@@ -12604,264 +11959,7 @@
           <a:noFill/>
         </p:spPr>
         <p:txBody>
-          <a:bodyPr wrap="square" anchor="t" lIns="25400" rIns="25400" tIns="12700" bIns="12700">
-            <a:spAutoFit/>
-          </a:bodyPr>
-          <a:lstStyle/>
-          <a:p>
-            <a:pPr algn="l">
-              <a:lnSpc>
-                <a:spcPct val="105000"/>
-              </a:lnSpc>
-              <a:spcBef>
-                <a:spcPts val="0"/>
-              </a:spcBef>
-              <a:spcAft>
-                <a:spcPts val="1000"/>
-              </a:spcAft>
-            </a:pPr>
-            <a:r>
-              <a:rPr sz="2000" b="1" i="0">
-                <a:solidFill>
-                  <a:srgbClr val="C2410C"/>
-                </a:solidFill>
-                <a:latin typeface="Calibri"/>
-              </a:rPr>
-              <a:t>1.  </a:t>
-            </a:r>
-            <a:r>
-              <a:rPr sz="2000" b="1" i="0">
-                <a:solidFill>
-                  <a:srgbClr val="14241C"/>
-                </a:solidFill>
-                <a:latin typeface="Calibri"/>
-              </a:rPr>
-              <a:t>Add it to your home screen</a:t>
-            </a:r>
-            <a:r>
-              <a:rPr sz="2000" b="0" i="0">
-                <a:solidFill>
-                  <a:srgbClr val="14241C"/>
-                </a:solidFill>
-                <a:latin typeface="Calibri"/>
-              </a:rPr>
-              <a:t>  — so it's one tap away.</a:t>
-            </a:r>
-          </a:p>
-          <a:p>
-            <a:pPr algn="l">
-              <a:lnSpc>
-                <a:spcPct val="105000"/>
-              </a:lnSpc>
-              <a:spcBef>
-                <a:spcPts val="0"/>
-              </a:spcBef>
-              <a:spcAft>
-                <a:spcPts val="1000"/>
-              </a:spcAft>
-            </a:pPr>
-            <a:r>
-              <a:rPr sz="2000" b="1" i="0">
-                <a:solidFill>
-                  <a:srgbClr val="C2410C"/>
-                </a:solidFill>
-                <a:latin typeface="Calibri"/>
-              </a:rPr>
-              <a:t>2.  </a:t>
-            </a:r>
-            <a:r>
-              <a:rPr sz="2000" b="1" i="0">
-                <a:solidFill>
-                  <a:srgbClr val="14241C"/>
-                </a:solidFill>
-                <a:latin typeface="Calibri"/>
-              </a:rPr>
-              <a:t>Sign in with your email</a:t>
-            </a:r>
-            <a:r>
-              <a:rPr sz="2000" b="0" i="0">
-                <a:solidFill>
-                  <a:srgbClr val="14241C"/>
-                </a:solidFill>
-                <a:latin typeface="Calibri"/>
-              </a:rPr>
-              <a:t>  — name + the 6-digit code, no password.</a:t>
-            </a:r>
-          </a:p>
-          <a:p>
-            <a:pPr algn="l">
-              <a:lnSpc>
-                <a:spcPct val="105000"/>
-              </a:lnSpc>
-              <a:spcBef>
-                <a:spcPts val="0"/>
-              </a:spcBef>
-              <a:spcAft>
-                <a:spcPts val="1000"/>
-              </a:spcAft>
-            </a:pPr>
-            <a:r>
-              <a:rPr sz="2000" b="1" i="0">
-                <a:solidFill>
-                  <a:srgbClr val="C2410C"/>
-                </a:solidFill>
-                <a:latin typeface="Calibri"/>
-              </a:rPr>
-              <a:t>3.  </a:t>
-            </a:r>
-            <a:r>
-              <a:rPr sz="2000" b="1" i="0">
-                <a:solidFill>
-                  <a:srgbClr val="14241C"/>
-                </a:solidFill>
-                <a:latin typeface="Calibri"/>
-              </a:rPr>
-              <a:t>RSVP to Family Fest</a:t>
-            </a:r>
-            <a:r>
-              <a:rPr sz="2000" b="0" i="0">
-                <a:solidFill>
-                  <a:srgbClr val="14241C"/>
-                </a:solidFill>
-                <a:latin typeface="Calibri"/>
-              </a:rPr>
-              <a:t>  — tell us which days, July 27–31.</a:t>
-            </a:r>
-          </a:p>
-          <a:p>
-            <a:pPr algn="l">
-              <a:lnSpc>
-                <a:spcPct val="105000"/>
-              </a:lnSpc>
-              <a:spcBef>
-                <a:spcPts val="0"/>
-              </a:spcBef>
-              <a:spcAft>
-                <a:spcPts val="1000"/>
-              </a:spcAft>
-            </a:pPr>
-            <a:r>
-              <a:rPr sz="1800" b="1" i="0">
-                <a:solidFill>
-                  <a:srgbClr val="15503A"/>
-                </a:solidFill>
-                <a:latin typeface="Calibri"/>
-              </a:rPr>
-              <a:t>“Do those three today and you're all set. Post a photo this week so we know it's working — and I'm right here if anyone gets stuck.”</a:t>
-            </a:r>
-          </a:p>
-        </p:txBody>
-      </p:sp>
-      <p:sp>
-        <p:nvSpPr>
-          <p:cNvPr id="11" name="Rounded Rectangle 10"/>
-          <p:cNvSpPr/>
-          <p:nvPr/>
-        </p:nvSpPr>
-        <p:spPr>
-          <a:xfrm>
-            <a:off x="365760" y="6510528"/>
-            <a:ext cx="11521440" cy="63500"/>
-          </a:xfrm>
-          <a:prstGeom prst="roundRect">
-            <a:avLst>
-              <a:gd name="adj" fmla="val 6000"/>
-            </a:avLst>
-          </a:prstGeom>
-          <a:solidFill>
-            <a:srgbClr val="E5E4DA"/>
-          </a:solidFill>
-          <a:ln>
-            <a:noFill/>
-          </a:ln>
-          <a:effectLst/>
-        </p:spPr>
-        <p:style>
-          <a:lnRef idx="1">
-            <a:schemeClr val="accent1"/>
-          </a:lnRef>
-          <a:fillRef idx="3">
-            <a:schemeClr val="accent1"/>
-          </a:fillRef>
-          <a:effectRef idx="2">
-            <a:schemeClr val="accent1"/>
-          </a:effectRef>
-          <a:fontRef idx="minor">
-            <a:schemeClr val="lt1"/>
-          </a:fontRef>
-        </p:style>
-        <p:txBody>
-          <a:bodyPr rtlCol="0" anchor="ctr"/>
-          <a:lstStyle/>
-          <a:p>
-            <a:pPr algn="ctr"/>
-          </a:p>
-        </p:txBody>
-      </p:sp>
-      <p:sp>
-        <p:nvSpPr>
-          <p:cNvPr id="12" name="Rounded Rectangle 11"/>
-          <p:cNvSpPr/>
-          <p:nvPr/>
-        </p:nvSpPr>
-        <p:spPr>
-          <a:xfrm>
-            <a:off x="365760" y="6510528"/>
-            <a:ext cx="11521440" cy="63500"/>
-          </a:xfrm>
-          <a:prstGeom prst="roundRect">
-            <a:avLst>
-              <a:gd name="adj" fmla="val 6000"/>
-            </a:avLst>
-          </a:prstGeom>
-          <a:solidFill>
-            <a:srgbClr val="C2410C"/>
-          </a:solidFill>
-          <a:ln>
-            <a:noFill/>
-          </a:ln>
-          <a:effectLst/>
-        </p:spPr>
-        <p:style>
-          <a:lnRef idx="1">
-            <a:schemeClr val="accent1"/>
-          </a:lnRef>
-          <a:fillRef idx="3">
-            <a:schemeClr val="accent1"/>
-          </a:fillRef>
-          <a:effectRef idx="2">
-            <a:schemeClr val="accent1"/>
-          </a:effectRef>
-          <a:fontRef idx="minor">
-            <a:schemeClr val="lt1"/>
-          </a:fontRef>
-        </p:style>
-        <p:txBody>
-          <a:bodyPr rtlCol="0" anchor="ctr"/>
-          <a:lstStyle/>
-          <a:p>
-            <a:pPr algn="ctr"/>
-          </a:p>
-        </p:txBody>
-      </p:sp>
-      <p:sp>
-        <p:nvSpPr>
-          <p:cNvPr id="13" name="TextBox 12"/>
-          <p:cNvSpPr txBox="1"/>
-          <p:nvPr/>
-        </p:nvSpPr>
-        <p:spPr>
-          <a:xfrm>
-            <a:off x="365760" y="6163056"/>
-            <a:ext cx="11430000" cy="292608"/>
-          </a:xfrm>
-          <a:prstGeom prst="rect">
-            <a:avLst/>
-          </a:prstGeom>
-          <a:noFill/>
-        </p:spPr>
-        <p:txBody>
-          <a:bodyPr wrap="square" anchor="t" lIns="25400" rIns="25400" tIns="12700" bIns="12700">
+          <a:bodyPr wrap="square" anchor="ctr" lIns="25400" rIns="25400" tIns="12700" bIns="12700">
             <a:spAutoFit/>
           </a:bodyPr>
           <a:lstStyle/>
@@ -12878,6 +11976,601 @@
               </a:spcAft>
             </a:pPr>
             <a:r>
+              <a:rPr sz="1500" b="1" i="0">
+                <a:solidFill>
+                  <a:srgbClr val="14241C"/>
+                </a:solidFill>
+                <a:latin typeface="Calibri"/>
+              </a:rPr>
+              <a:t>Profile  →  Text size  ·  Help page</a:t>
+            </a:r>
+          </a:p>
+        </p:txBody>
+      </p:sp>
+      <p:sp>
+        <p:nvSpPr>
+          <p:cNvPr id="11" name="Rounded Rectangle 10"/>
+          <p:cNvSpPr/>
+          <p:nvPr/>
+        </p:nvSpPr>
+        <p:spPr>
+          <a:xfrm>
+            <a:off x="502920" y="2029968"/>
+            <a:ext cx="11201400" cy="786384"/>
+          </a:xfrm>
+          <a:prstGeom prst="roundRect">
+            <a:avLst>
+              <a:gd name="adj" fmla="val 6000"/>
+            </a:avLst>
+          </a:prstGeom>
+          <a:solidFill>
+            <a:srgbClr val="FBF7EC"/>
+          </a:solidFill>
+          <a:ln w="12700">
+            <a:solidFill>
+              <a:srgbClr val="E6D9B8"/>
+            </a:solidFill>
+          </a:ln>
+          <a:effectLst/>
+        </p:spPr>
+        <p:style>
+          <a:lnRef idx="1">
+            <a:schemeClr val="accent1"/>
+          </a:lnRef>
+          <a:fillRef idx="3">
+            <a:schemeClr val="accent1"/>
+          </a:fillRef>
+          <a:effectRef idx="2">
+            <a:schemeClr val="accent1"/>
+          </a:effectRef>
+          <a:fontRef idx="minor">
+            <a:schemeClr val="lt1"/>
+          </a:fontRef>
+        </p:style>
+        <p:txBody>
+          <a:bodyPr rtlCol="0" anchor="ctr"/>
+          <a:lstStyle/>
+          <a:p>
+            <a:pPr algn="ctr"/>
+          </a:p>
+        </p:txBody>
+      </p:sp>
+      <p:sp>
+        <p:nvSpPr>
+          <p:cNvPr id="12" name="Rectangle 11"/>
+          <p:cNvSpPr/>
+          <p:nvPr/>
+        </p:nvSpPr>
+        <p:spPr>
+          <a:xfrm>
+            <a:off x="502920" y="2029968"/>
+            <a:ext cx="91440" cy="786384"/>
+          </a:xfrm>
+          <a:prstGeom prst="rect">
+            <a:avLst/>
+          </a:prstGeom>
+          <a:solidFill>
+            <a:srgbClr val="C2410C"/>
+          </a:solidFill>
+          <a:ln>
+            <a:noFill/>
+          </a:ln>
+          <a:effectLst/>
+        </p:spPr>
+        <p:style>
+          <a:lnRef idx="1">
+            <a:schemeClr val="accent1"/>
+          </a:lnRef>
+          <a:fillRef idx="3">
+            <a:schemeClr val="accent1"/>
+          </a:fillRef>
+          <a:effectRef idx="2">
+            <a:schemeClr val="accent1"/>
+          </a:effectRef>
+          <a:fontRef idx="minor">
+            <a:schemeClr val="lt1"/>
+          </a:fontRef>
+        </p:style>
+        <p:txBody>
+          <a:bodyPr rtlCol="0" anchor="ctr"/>
+          <a:lstStyle/>
+          <a:p>
+            <a:pPr algn="ctr"/>
+          </a:p>
+        </p:txBody>
+      </p:sp>
+      <p:sp>
+        <p:nvSpPr>
+          <p:cNvPr id="13" name="TextBox 12"/>
+          <p:cNvSpPr txBox="1"/>
+          <p:nvPr/>
+        </p:nvSpPr>
+        <p:spPr>
+          <a:xfrm>
+            <a:off x="813816" y="2029968"/>
+            <a:ext cx="10698480" cy="786384"/>
+          </a:xfrm>
+          <a:prstGeom prst="rect">
+            <a:avLst/>
+          </a:prstGeom>
+          <a:noFill/>
+        </p:spPr>
+        <p:txBody>
+          <a:bodyPr wrap="square" anchor="ctr" lIns="25400" rIns="25400" tIns="12700" bIns="12700">
+            <a:spAutoFit/>
+          </a:bodyPr>
+          <a:lstStyle/>
+          <a:p>
+            <a:pPr algn="l">
+              <a:lnSpc>
+                <a:spcPct val="100000"/>
+              </a:lnSpc>
+              <a:spcBef>
+                <a:spcPts val="0"/>
+              </a:spcBef>
+              <a:spcAft>
+                <a:spcPts val="400"/>
+              </a:spcAft>
+            </a:pPr>
+            <a:r>
+              <a:rPr sz="1800" b="1" i="0">
+                <a:solidFill>
+                  <a:srgbClr val="14241C"/>
+                </a:solidFill>
+                <a:latin typeface="Calibri"/>
+              </a:rPr>
+              <a:t>It's just us — family only — and we made it easy for every age to use.</a:t>
+            </a:r>
+          </a:p>
+        </p:txBody>
+      </p:sp>
+      <p:sp>
+        <p:nvSpPr>
+          <p:cNvPr id="14" name="TextBox 13"/>
+          <p:cNvSpPr txBox="1"/>
+          <p:nvPr/>
+        </p:nvSpPr>
+        <p:spPr>
+          <a:xfrm>
+            <a:off x="594360" y="3035808"/>
+            <a:ext cx="11018520" cy="2468880"/>
+          </a:xfrm>
+          <a:prstGeom prst="rect">
+            <a:avLst/>
+          </a:prstGeom>
+          <a:noFill/>
+        </p:spPr>
+        <p:txBody>
+          <a:bodyPr wrap="square" anchor="t" lIns="25400" rIns="25400" tIns="12700" bIns="12700">
+            <a:spAutoFit/>
+          </a:bodyPr>
+          <a:lstStyle/>
+          <a:p>
+            <a:pPr algn="l">
+              <a:lnSpc>
+                <a:spcPct val="100000"/>
+              </a:lnSpc>
+              <a:spcBef>
+                <a:spcPts val="0"/>
+              </a:spcBef>
+              <a:spcAft>
+                <a:spcPts val="1000"/>
+              </a:spcAft>
+            </a:pPr>
+            <a:r>
+              <a:rPr sz="1600" b="1" i="0">
+                <a:solidFill>
+                  <a:srgbClr val="15503A"/>
+                </a:solidFill>
+                <a:latin typeface="Calibri"/>
+              </a:rPr>
+              <a:t>•  </a:t>
+            </a:r>
+            <a:r>
+              <a:rPr sz="1600" b="1" i="0">
+                <a:solidFill>
+                  <a:srgbClr val="14241C"/>
+                </a:solidFill>
+                <a:latin typeface="Calibri"/>
+              </a:rPr>
+              <a:t>Family only</a:t>
+            </a:r>
+            <a:r>
+              <a:rPr sz="1600" b="0" i="0">
+                <a:solidFill>
+                  <a:srgbClr val="14241C"/>
+                </a:solidFill>
+                <a:latin typeface="Calibri"/>
+              </a:rPr>
+              <a:t> — not public; sensitive info hidden until you sign in</a:t>
+            </a:r>
+          </a:p>
+          <a:p>
+            <a:pPr algn="l">
+              <a:lnSpc>
+                <a:spcPct val="100000"/>
+              </a:lnSpc>
+              <a:spcBef>
+                <a:spcPts val="0"/>
+              </a:spcBef>
+              <a:spcAft>
+                <a:spcPts val="1000"/>
+              </a:spcAft>
+            </a:pPr>
+            <a:r>
+              <a:rPr sz="1600" b="1" i="0">
+                <a:solidFill>
+                  <a:srgbClr val="15503A"/>
+                </a:solidFill>
+                <a:latin typeface="Calibri"/>
+              </a:rPr>
+              <a:t>•  </a:t>
+            </a:r>
+            <a:r>
+              <a:rPr sz="1600" b="1" i="0">
+                <a:solidFill>
+                  <a:srgbClr val="14241C"/>
+                </a:solidFill>
+                <a:latin typeface="Calibri"/>
+              </a:rPr>
+              <a:t>Bigger text</a:t>
+            </a:r>
+            <a:r>
+              <a:rPr sz="1600" b="0" i="0">
+                <a:solidFill>
+                  <a:srgbClr val="14241C"/>
+                </a:solidFill>
+                <a:latin typeface="Calibri"/>
+              </a:rPr>
+              <a:t> — Profile → Text size: Normal / Large / Largest</a:t>
+            </a:r>
+          </a:p>
+          <a:p>
+            <a:pPr algn="l">
+              <a:lnSpc>
+                <a:spcPct val="100000"/>
+              </a:lnSpc>
+              <a:spcBef>
+                <a:spcPts val="0"/>
+              </a:spcBef>
+              <a:spcAft>
+                <a:spcPts val="1000"/>
+              </a:spcAft>
+            </a:pPr>
+            <a:r>
+              <a:rPr sz="1600" b="1" i="0">
+                <a:solidFill>
+                  <a:srgbClr val="15503A"/>
+                </a:solidFill>
+                <a:latin typeface="Calibri"/>
+              </a:rPr>
+              <a:t>•  </a:t>
+            </a:r>
+            <a:r>
+              <a:rPr sz="1600" b="1" i="0">
+                <a:solidFill>
+                  <a:srgbClr val="14241C"/>
+                </a:solidFill>
+                <a:latin typeface="Calibri"/>
+              </a:rPr>
+              <a:t>Help page</a:t>
+            </a:r>
+            <a:r>
+              <a:rPr sz="1600" b="0" i="0">
+                <a:solidFill>
+                  <a:srgbClr val="14241C"/>
+                </a:solidFill>
+                <a:latin typeface="Calibri"/>
+              </a:rPr>
+              <a:t> — plain-language how-tos for anyone stuck</a:t>
+            </a:r>
+          </a:p>
+          <a:p>
+            <a:pPr algn="l">
+              <a:lnSpc>
+                <a:spcPct val="100000"/>
+              </a:lnSpc>
+              <a:spcBef>
+                <a:spcPts val="0"/>
+              </a:spcBef>
+              <a:spcAft>
+                <a:spcPts val="1000"/>
+              </a:spcAft>
+            </a:pPr>
+            <a:r>
+              <a:rPr sz="1600" b="1" i="0">
+                <a:solidFill>
+                  <a:srgbClr val="15503A"/>
+                </a:solidFill>
+                <a:latin typeface="Calibri"/>
+              </a:rPr>
+              <a:t>•  </a:t>
+            </a:r>
+            <a:r>
+              <a:rPr sz="1600" b="1" i="0">
+                <a:solidFill>
+                  <a:srgbClr val="14241C"/>
+                </a:solidFill>
+                <a:latin typeface="Calibri"/>
+              </a:rPr>
+              <a:t>A real person</a:t>
+            </a:r>
+            <a:r>
+              <a:rPr sz="1600" b="0" i="0">
+                <a:solidFill>
+                  <a:srgbClr val="14241C"/>
+                </a:solidFill>
+                <a:latin typeface="Calibri"/>
+              </a:rPr>
+              <a:t> — text or call me (Brian) anytime — it's on the Help page</a:t>
+            </a:r>
+          </a:p>
+        </p:txBody>
+      </p:sp>
+      <p:sp>
+        <p:nvSpPr>
+          <p:cNvPr id="15" name="Rounded Rectangle 14"/>
+          <p:cNvSpPr/>
+          <p:nvPr/>
+        </p:nvSpPr>
+        <p:spPr>
+          <a:xfrm>
+            <a:off x="502920" y="5486400"/>
+            <a:ext cx="11201400" cy="566928"/>
+          </a:xfrm>
+          <a:prstGeom prst="roundRect">
+            <a:avLst>
+              <a:gd name="adj" fmla="val 6000"/>
+            </a:avLst>
+          </a:prstGeom>
+          <a:solidFill>
+            <a:srgbClr val="F3EEF0"/>
+          </a:solidFill>
+          <a:ln w="12700">
+            <a:solidFill>
+              <a:srgbClr val="E5E4DA"/>
+            </a:solidFill>
+          </a:ln>
+          <a:effectLst/>
+        </p:spPr>
+        <p:style>
+          <a:lnRef idx="1">
+            <a:schemeClr val="accent1"/>
+          </a:lnRef>
+          <a:fillRef idx="3">
+            <a:schemeClr val="accent1"/>
+          </a:fillRef>
+          <a:effectRef idx="2">
+            <a:schemeClr val="accent1"/>
+          </a:effectRef>
+          <a:fontRef idx="minor">
+            <a:schemeClr val="lt1"/>
+          </a:fontRef>
+        </p:style>
+        <p:txBody>
+          <a:bodyPr rtlCol="0" anchor="ctr"/>
+          <a:lstStyle/>
+          <a:p>
+            <a:pPr algn="ctr"/>
+          </a:p>
+        </p:txBody>
+      </p:sp>
+      <p:sp>
+        <p:nvSpPr>
+          <p:cNvPr id="16" name="TextBox 15"/>
+          <p:cNvSpPr txBox="1"/>
+          <p:nvPr/>
+        </p:nvSpPr>
+        <p:spPr>
+          <a:xfrm>
+            <a:off x="667512" y="5486400"/>
+            <a:ext cx="1828800" cy="566928"/>
+          </a:xfrm>
+          <a:prstGeom prst="rect">
+            <a:avLst/>
+          </a:prstGeom>
+          <a:noFill/>
+        </p:spPr>
+        <p:txBody>
+          <a:bodyPr wrap="square" anchor="ctr" lIns="25400" rIns="25400" tIns="12700" bIns="12700">
+            <a:spAutoFit/>
+          </a:bodyPr>
+          <a:lstStyle/>
+          <a:p>
+            <a:pPr algn="l">
+              <a:lnSpc>
+                <a:spcPct val="100000"/>
+              </a:lnSpc>
+              <a:spcBef>
+                <a:spcPts val="0"/>
+              </a:spcBef>
+              <a:spcAft>
+                <a:spcPts val="400"/>
+              </a:spcAft>
+            </a:pPr>
+            <a:r>
+              <a:rPr sz="1200" b="1" i="0">
+                <a:solidFill>
+                  <a:srgbClr val="8B2E2E"/>
+                </a:solidFill>
+                <a:latin typeface="Calibri"/>
+              </a:rPr>
+              <a:t>💡 GOOD TO KNOW</a:t>
+            </a:r>
+          </a:p>
+        </p:txBody>
+      </p:sp>
+      <p:sp>
+        <p:nvSpPr>
+          <p:cNvPr id="17" name="TextBox 16"/>
+          <p:cNvSpPr txBox="1"/>
+          <p:nvPr/>
+        </p:nvSpPr>
+        <p:spPr>
+          <a:xfrm>
+            <a:off x="2560320" y="5486400"/>
+            <a:ext cx="9006840" cy="566928"/>
+          </a:xfrm>
+          <a:prstGeom prst="rect">
+            <a:avLst/>
+          </a:prstGeom>
+          <a:noFill/>
+        </p:spPr>
+        <p:txBody>
+          <a:bodyPr wrap="square" anchor="ctr" lIns="25400" rIns="25400" tIns="12700" bIns="12700">
+            <a:spAutoFit/>
+          </a:bodyPr>
+          <a:lstStyle/>
+          <a:p>
+            <a:pPr algn="l">
+              <a:lnSpc>
+                <a:spcPct val="100000"/>
+              </a:lnSpc>
+              <a:spcBef>
+                <a:spcPts val="0"/>
+              </a:spcBef>
+              <a:spcAft>
+                <a:spcPts val="400"/>
+              </a:spcAft>
+            </a:pPr>
+            <a:r>
+              <a:rPr sz="1300" b="0" i="0">
+                <a:solidFill>
+                  <a:srgbClr val="14241C"/>
+                </a:solidFill>
+                <a:latin typeface="Calibri"/>
+              </a:rPr>
+              <a:t>“No strangers, no ads, no selling anything. It's our family's app.”</a:t>
+            </a:r>
+          </a:p>
+        </p:txBody>
+      </p:sp>
+      <p:sp>
+        <p:nvSpPr>
+          <p:cNvPr id="18" name="Rounded Rectangle 17"/>
+          <p:cNvSpPr/>
+          <p:nvPr/>
+        </p:nvSpPr>
+        <p:spPr>
+          <a:xfrm>
+            <a:off x="365760" y="6510528"/>
+            <a:ext cx="11521440" cy="63500"/>
+          </a:xfrm>
+          <a:prstGeom prst="roundRect">
+            <a:avLst>
+              <a:gd name="adj" fmla="val 6000"/>
+            </a:avLst>
+          </a:prstGeom>
+          <a:solidFill>
+            <a:srgbClr val="E5E4DA"/>
+          </a:solidFill>
+          <a:ln>
+            <a:noFill/>
+          </a:ln>
+          <a:effectLst/>
+        </p:spPr>
+        <p:style>
+          <a:lnRef idx="1">
+            <a:schemeClr val="accent1"/>
+          </a:lnRef>
+          <a:fillRef idx="3">
+            <a:schemeClr val="accent1"/>
+          </a:fillRef>
+          <a:effectRef idx="2">
+            <a:schemeClr val="accent1"/>
+          </a:effectRef>
+          <a:fontRef idx="minor">
+            <a:schemeClr val="lt1"/>
+          </a:fontRef>
+        </p:style>
+        <p:txBody>
+          <a:bodyPr rtlCol="0" anchor="ctr"/>
+          <a:lstStyle/>
+          <a:p>
+            <a:pPr algn="ctr"/>
+          </a:p>
+        </p:txBody>
+      </p:sp>
+      <p:sp>
+        <p:nvSpPr>
+          <p:cNvPr id="19" name="Rounded Rectangle 18"/>
+          <p:cNvSpPr/>
+          <p:nvPr/>
+        </p:nvSpPr>
+        <p:spPr>
+          <a:xfrm>
+            <a:off x="365760" y="6510528"/>
+            <a:ext cx="10801350" cy="63500"/>
+          </a:xfrm>
+          <a:prstGeom prst="roundRect">
+            <a:avLst>
+              <a:gd name="adj" fmla="val 6000"/>
+            </a:avLst>
+          </a:prstGeom>
+          <a:solidFill>
+            <a:srgbClr val="15503A"/>
+          </a:solidFill>
+          <a:ln>
+            <a:noFill/>
+          </a:ln>
+          <a:effectLst/>
+        </p:spPr>
+        <p:style>
+          <a:lnRef idx="1">
+            <a:schemeClr val="accent1"/>
+          </a:lnRef>
+          <a:fillRef idx="3">
+            <a:schemeClr val="accent1"/>
+          </a:fillRef>
+          <a:effectRef idx="2">
+            <a:schemeClr val="accent1"/>
+          </a:effectRef>
+          <a:fontRef idx="minor">
+            <a:schemeClr val="lt1"/>
+          </a:fontRef>
+        </p:style>
+        <p:txBody>
+          <a:bodyPr rtlCol="0" anchor="ctr"/>
+          <a:lstStyle/>
+          <a:p>
+            <a:pPr algn="ctr"/>
+          </a:p>
+        </p:txBody>
+      </p:sp>
+      <p:sp>
+        <p:nvSpPr>
+          <p:cNvPr id="20" name="TextBox 19"/>
+          <p:cNvSpPr txBox="1"/>
+          <p:nvPr/>
+        </p:nvSpPr>
+        <p:spPr>
+          <a:xfrm>
+            <a:off x="365760" y="6163056"/>
+            <a:ext cx="11430000" cy="292608"/>
+          </a:xfrm>
+          <a:prstGeom prst="rect">
+            <a:avLst/>
+          </a:prstGeom>
+          <a:noFill/>
+        </p:spPr>
+        <p:txBody>
+          <a:bodyPr wrap="square" anchor="t" lIns="25400" rIns="25400" tIns="12700" bIns="12700">
+            <a:spAutoFit/>
+          </a:bodyPr>
+          <a:lstStyle/>
+          <a:p>
+            <a:pPr algn="l">
+              <a:lnSpc>
+                <a:spcPct val="100000"/>
+              </a:lnSpc>
+              <a:spcBef>
+                <a:spcPts val="0"/>
+              </a:spcBef>
+              <a:spcAft>
+                <a:spcPts val="400"/>
+              </a:spcAft>
+            </a:pPr>
+            <a:r>
               <a:rPr sz="1100" b="1" i="0">
                 <a:solidFill>
                   <a:srgbClr val="6B7068"/>
@@ -12893,7 +12586,7 @@
                 </a:solidFill>
                 <a:latin typeface="Calibri"/>
               </a:rPr>
-              <a:t>Quick facts (for Q&amp;A)</a:t>
+              <a:t>What to do right now</a:t>
             </a:r>
           </a:p>
         </p:txBody>
@@ -12975,7 +12668,7 @@
             <a:avLst/>
           </a:prstGeom>
           <a:solidFill>
-            <a:srgbClr val="0C4029"/>
+            <a:srgbClr val="C2410C"/>
           </a:solidFill>
           <a:ln>
             <a:noFill/>
@@ -13006,14 +12699,105 @@
       </p:sp>
       <p:sp>
         <p:nvSpPr>
-          <p:cNvPr id="4" name="TextBox 3"/>
+          <p:cNvPr id="4" name="Rounded Rectangle 3"/>
+          <p:cNvSpPr/>
+          <p:nvPr/>
+        </p:nvSpPr>
+        <p:spPr>
+          <a:xfrm>
+            <a:off x="365760" y="201168"/>
+            <a:ext cx="1371600" cy="676656"/>
+          </a:xfrm>
+          <a:prstGeom prst="roundRect">
+            <a:avLst>
+              <a:gd name="adj" fmla="val 6000"/>
+            </a:avLst>
+          </a:prstGeom>
+          <a:solidFill>
+            <a:srgbClr val="FFFFFF"/>
+          </a:solidFill>
+          <a:ln>
+            <a:noFill/>
+          </a:ln>
+          <a:effectLst/>
+        </p:spPr>
+        <p:style>
+          <a:lnRef idx="1">
+            <a:schemeClr val="accent1"/>
+          </a:lnRef>
+          <a:fillRef idx="3">
+            <a:schemeClr val="accent1"/>
+          </a:fillRef>
+          <a:effectRef idx="2">
+            <a:schemeClr val="accent1"/>
+          </a:effectRef>
+          <a:fontRef idx="minor">
+            <a:schemeClr val="lt1"/>
+          </a:fontRef>
+        </p:style>
+        <p:txBody>
+          <a:bodyPr rtlCol="0" anchor="ctr"/>
+          <a:lstStyle/>
+          <a:p>
+            <a:pPr algn="ctr"/>
+          </a:p>
+        </p:txBody>
+      </p:sp>
+      <p:sp>
+        <p:nvSpPr>
+          <p:cNvPr id="5" name="TextBox 4"/>
           <p:cNvSpPr txBox="1"/>
           <p:nvPr/>
         </p:nvSpPr>
         <p:spPr>
           <a:xfrm>
-            <a:off x="457200" y="146304"/>
-            <a:ext cx="10972800" cy="786384"/>
+            <a:off x="365760" y="219456"/>
+            <a:ext cx="1371600" cy="640080"/>
+          </a:xfrm>
+          <a:prstGeom prst="rect">
+            <a:avLst/>
+          </a:prstGeom>
+          <a:noFill/>
+        </p:spPr>
+        <p:txBody>
+          <a:bodyPr wrap="square" anchor="ctr" lIns="25400" rIns="25400" tIns="12700" bIns="12700">
+            <a:spAutoFit/>
+          </a:bodyPr>
+          <a:lstStyle/>
+          <a:p>
+            <a:pPr algn="ctr">
+              <a:lnSpc>
+                <a:spcPct val="100000"/>
+              </a:lnSpc>
+              <a:spcBef>
+                <a:spcPts val="0"/>
+              </a:spcBef>
+              <a:spcAft>
+                <a:spcPts val="400"/>
+              </a:spcAft>
+            </a:pPr>
+            <a:r>
+              <a:rPr sz="2200" b="1" i="0">
+                <a:solidFill>
+                  <a:srgbClr val="C2410C"/>
+                </a:solidFill>
+                <a:latin typeface="Calibri"/>
+              </a:rPr>
+              <a:t>STEP 16</a:t>
+            </a:r>
+          </a:p>
+        </p:txBody>
+      </p:sp>
+      <p:sp>
+        <p:nvSpPr>
+          <p:cNvPr id="6" name="TextBox 5"/>
+          <p:cNvSpPr txBox="1"/>
+          <p:nvPr/>
+        </p:nvSpPr>
+        <p:spPr>
+          <a:xfrm>
+            <a:off x="1920240" y="146304"/>
+            <a:ext cx="8595360" cy="786384"/>
           </a:xfrm>
           <a:prstGeom prst="rect">
             <a:avLst/>
@@ -13044,69 +12828,66 @@
                 </a:solidFill>
                 <a:latin typeface="Calibri"/>
               </a:rPr>
-              <a:t>Quick facts  ·  for live Q&amp;A</a:t>
-            </a:r>
-          </a:p>
-        </p:txBody>
-      </p:sp>
-      <p:sp>
-        <p:nvSpPr>
-          <p:cNvPr id="5" name="Rounded Rectangle 4"/>
-          <p:cNvSpPr/>
-          <p:nvPr/>
-        </p:nvSpPr>
-        <p:spPr>
-          <a:xfrm>
-            <a:off x="457200" y="1371600"/>
-            <a:ext cx="5486400" cy="1078992"/>
-          </a:xfrm>
-          <a:prstGeom prst="roundRect">
-            <a:avLst>
-              <a:gd name="adj" fmla="val 6000"/>
-            </a:avLst>
-          </a:prstGeom>
-          <a:solidFill>
-            <a:srgbClr val="FFFFFF"/>
-          </a:solidFill>
-          <a:ln w="12700">
-            <a:solidFill>
-              <a:srgbClr val="E5E4DA"/>
-            </a:solidFill>
-          </a:ln>
-          <a:effectLst/>
-        </p:spPr>
-        <p:style>
-          <a:lnRef idx="1">
-            <a:schemeClr val="accent1"/>
-          </a:lnRef>
-          <a:fillRef idx="3">
-            <a:schemeClr val="accent1"/>
-          </a:fillRef>
-          <a:effectRef idx="2">
-            <a:schemeClr val="accent1"/>
-          </a:effectRef>
-          <a:fontRef idx="minor">
-            <a:schemeClr val="lt1"/>
-          </a:fontRef>
-        </p:style>
-        <p:txBody>
-          <a:bodyPr rtlCol="0" anchor="ctr"/>
-          <a:lstStyle/>
-          <a:p>
-            <a:pPr algn="ctr"/>
-          </a:p>
-        </p:txBody>
-      </p:sp>
-      <p:sp>
-        <p:nvSpPr>
-          <p:cNvPr id="6" name="TextBox 5"/>
+              <a:t>BEFORE YOU LEAVE</a:t>
+            </a:r>
+          </a:p>
+        </p:txBody>
+      </p:sp>
+      <p:sp>
+        <p:nvSpPr>
+          <p:cNvPr id="7" name="TextBox 6"/>
           <p:cNvSpPr txBox="1"/>
           <p:nvPr/>
         </p:nvSpPr>
         <p:spPr>
           <a:xfrm>
-            <a:off x="685800" y="1481328"/>
-            <a:ext cx="5029200" cy="365760"/>
+            <a:off x="9509760" y="146304"/>
+            <a:ext cx="2377440" cy="786384"/>
+          </a:xfrm>
+          <a:prstGeom prst="rect">
+            <a:avLst/>
+          </a:prstGeom>
+          <a:noFill/>
+        </p:spPr>
+        <p:txBody>
+          <a:bodyPr wrap="square" anchor="ctr" lIns="25400" rIns="25400" tIns="12700" bIns="12700">
+            <a:spAutoFit/>
+          </a:bodyPr>
+          <a:lstStyle/>
+          <a:p>
+            <a:pPr algn="r">
+              <a:lnSpc>
+                <a:spcPct val="100000"/>
+              </a:lnSpc>
+              <a:spcBef>
+                <a:spcPts val="0"/>
+              </a:spcBef>
+              <a:spcAft>
+                <a:spcPts val="400"/>
+              </a:spcAft>
+            </a:pPr>
+            <a:r>
+              <a:rPr sz="1300" b="0" i="0">
+                <a:solidFill>
+                  <a:srgbClr val="ECF3EF"/>
+                </a:solidFill>
+                <a:latin typeface="Calibri"/>
+              </a:rPr>
+              <a:t>Step 16 of 16</a:t>
+            </a:r>
+          </a:p>
+        </p:txBody>
+      </p:sp>
+      <p:sp>
+        <p:nvSpPr>
+          <p:cNvPr id="8" name="TextBox 7"/>
+          <p:cNvSpPr txBox="1"/>
+          <p:nvPr/>
+        </p:nvSpPr>
+        <p:spPr>
+          <a:xfrm>
+            <a:off x="640080" y="1371600"/>
+            <a:ext cx="10972800" cy="914400"/>
           </a:xfrm>
           <a:prstGeom prst="rect">
             <a:avLst/>
@@ -13131,27 +12912,363 @@
               </a:spcAft>
             </a:pPr>
             <a:r>
+              <a:rPr sz="3200" b="1" i="0">
+                <a:solidFill>
+                  <a:srgbClr val="14241C"/>
+                </a:solidFill>
+                <a:latin typeface="Calibri"/>
+              </a:rPr>
+              <a:t>Three things to do right now</a:t>
+            </a:r>
+          </a:p>
+        </p:txBody>
+      </p:sp>
+      <p:sp>
+        <p:nvSpPr>
+          <p:cNvPr id="9" name="Rounded Rectangle 8"/>
+          <p:cNvSpPr/>
+          <p:nvPr/>
+        </p:nvSpPr>
+        <p:spPr>
+          <a:xfrm>
+            <a:off x="640080" y="2331720"/>
+            <a:ext cx="10908792" cy="3566160"/>
+          </a:xfrm>
+          <a:prstGeom prst="roundRect">
+            <a:avLst>
+              <a:gd name="adj" fmla="val 6000"/>
+            </a:avLst>
+          </a:prstGeom>
+          <a:solidFill>
+            <a:srgbClr val="FFFFFF"/>
+          </a:solidFill>
+          <a:ln w="12700">
+            <a:solidFill>
+              <a:srgbClr val="E5E4DA"/>
+            </a:solidFill>
+          </a:ln>
+          <a:effectLst/>
+        </p:spPr>
+        <p:style>
+          <a:lnRef idx="1">
+            <a:schemeClr val="accent1"/>
+          </a:lnRef>
+          <a:fillRef idx="3">
+            <a:schemeClr val="accent1"/>
+          </a:fillRef>
+          <a:effectRef idx="2">
+            <a:schemeClr val="accent1"/>
+          </a:effectRef>
+          <a:fontRef idx="minor">
+            <a:schemeClr val="lt1"/>
+          </a:fontRef>
+        </p:style>
+        <p:txBody>
+          <a:bodyPr rtlCol="0" anchor="ctr"/>
+          <a:lstStyle/>
+          <a:p>
+            <a:pPr algn="ctr"/>
+          </a:p>
+        </p:txBody>
+      </p:sp>
+      <p:sp>
+        <p:nvSpPr>
+          <p:cNvPr id="10" name="TextBox 9"/>
+          <p:cNvSpPr txBox="1"/>
+          <p:nvPr/>
+        </p:nvSpPr>
+        <p:spPr>
+          <a:xfrm>
+            <a:off x="1005840" y="2606040"/>
+            <a:ext cx="10149840" cy="3108960"/>
+          </a:xfrm>
+          <a:prstGeom prst="rect">
+            <a:avLst/>
+          </a:prstGeom>
+          <a:noFill/>
+        </p:spPr>
+        <p:txBody>
+          <a:bodyPr wrap="square" anchor="t" lIns="25400" rIns="25400" tIns="12700" bIns="12700">
+            <a:spAutoFit/>
+          </a:bodyPr>
+          <a:lstStyle/>
+          <a:p>
+            <a:pPr algn="l">
+              <a:lnSpc>
+                <a:spcPct val="105000"/>
+              </a:lnSpc>
+              <a:spcBef>
+                <a:spcPts val="0"/>
+              </a:spcBef>
+              <a:spcAft>
+                <a:spcPts val="1000"/>
+              </a:spcAft>
+            </a:pPr>
+            <a:r>
+              <a:rPr sz="2000" b="1" i="0">
+                <a:solidFill>
+                  <a:srgbClr val="C2410C"/>
+                </a:solidFill>
+                <a:latin typeface="Calibri"/>
+              </a:rPr>
+              <a:t>1.  </a:t>
+            </a:r>
+            <a:r>
+              <a:rPr sz="2000" b="1" i="0">
+                <a:solidFill>
+                  <a:srgbClr val="14241C"/>
+                </a:solidFill>
+                <a:latin typeface="Calibri"/>
+              </a:rPr>
+              <a:t>Add it to your home screen</a:t>
+            </a:r>
+            <a:r>
+              <a:rPr sz="2000" b="0" i="0">
+                <a:solidFill>
+                  <a:srgbClr val="14241C"/>
+                </a:solidFill>
+                <a:latin typeface="Calibri"/>
+              </a:rPr>
+              <a:t>  — so it's one tap away.</a:t>
+            </a:r>
+          </a:p>
+          <a:p>
+            <a:pPr algn="l">
+              <a:lnSpc>
+                <a:spcPct val="105000"/>
+              </a:lnSpc>
+              <a:spcBef>
+                <a:spcPts val="0"/>
+              </a:spcBef>
+              <a:spcAft>
+                <a:spcPts val="1000"/>
+              </a:spcAft>
+            </a:pPr>
+            <a:r>
+              <a:rPr sz="2000" b="1" i="0">
+                <a:solidFill>
+                  <a:srgbClr val="C2410C"/>
+                </a:solidFill>
+                <a:latin typeface="Calibri"/>
+              </a:rPr>
+              <a:t>2.  </a:t>
+            </a:r>
+            <a:r>
+              <a:rPr sz="2000" b="1" i="0">
+                <a:solidFill>
+                  <a:srgbClr val="14241C"/>
+                </a:solidFill>
+                <a:latin typeface="Calibri"/>
+              </a:rPr>
+              <a:t>Sign in with your email</a:t>
+            </a:r>
+            <a:r>
+              <a:rPr sz="2000" b="0" i="0">
+                <a:solidFill>
+                  <a:srgbClr val="14241C"/>
+                </a:solidFill>
+                <a:latin typeface="Calibri"/>
+              </a:rPr>
+              <a:t>  — name + the 6-digit code, no password.</a:t>
+            </a:r>
+          </a:p>
+          <a:p>
+            <a:pPr algn="l">
+              <a:lnSpc>
+                <a:spcPct val="105000"/>
+              </a:lnSpc>
+              <a:spcBef>
+                <a:spcPts val="0"/>
+              </a:spcBef>
+              <a:spcAft>
+                <a:spcPts val="1000"/>
+              </a:spcAft>
+            </a:pPr>
+            <a:r>
+              <a:rPr sz="2000" b="1" i="0">
+                <a:solidFill>
+                  <a:srgbClr val="C2410C"/>
+                </a:solidFill>
+                <a:latin typeface="Calibri"/>
+              </a:rPr>
+              <a:t>3.  </a:t>
+            </a:r>
+            <a:r>
+              <a:rPr sz="2000" b="1" i="0">
+                <a:solidFill>
+                  <a:srgbClr val="14241C"/>
+                </a:solidFill>
+                <a:latin typeface="Calibri"/>
+              </a:rPr>
+              <a:t>RSVP to Family Fest</a:t>
+            </a:r>
+            <a:r>
+              <a:rPr sz="2000" b="0" i="0">
+                <a:solidFill>
+                  <a:srgbClr val="14241C"/>
+                </a:solidFill>
+                <a:latin typeface="Calibri"/>
+              </a:rPr>
+              <a:t>  — tell us which days, July 27–31.</a:t>
+            </a:r>
+          </a:p>
+          <a:p>
+            <a:pPr algn="l">
+              <a:lnSpc>
+                <a:spcPct val="105000"/>
+              </a:lnSpc>
+              <a:spcBef>
+                <a:spcPts val="0"/>
+              </a:spcBef>
+              <a:spcAft>
+                <a:spcPts val="1000"/>
+              </a:spcAft>
+            </a:pPr>
+            <a:r>
+              <a:rPr sz="1800" b="1" i="0">
+                <a:solidFill>
+                  <a:srgbClr val="15503A"/>
+                </a:solidFill>
+                <a:latin typeface="Calibri"/>
+              </a:rPr>
+              <a:t>“Do those three today and you're all set. Post a photo this week so we know it's working — and I'm right here if anyone gets stuck.”</a:t>
+            </a:r>
+          </a:p>
+          <a:p>
+            <a:pPr algn="l">
+              <a:lnSpc>
+                <a:spcPct val="105000"/>
+              </a:lnSpc>
+              <a:spcBef>
+                <a:spcPts val="0"/>
+              </a:spcBef>
+              <a:spcAft>
+                <a:spcPts val="1000"/>
+              </a:spcAft>
+            </a:pPr>
+            <a:r>
               <a:rPr sz="1600" b="1" i="0">
                 <a:solidFill>
+                  <a:srgbClr val="6B7068"/>
+                </a:solidFill>
+                <a:latin typeface="Calibri"/>
+              </a:rPr>
+              <a:t>Get it at  </a:t>
+            </a:r>
+            <a:r>
+              <a:rPr sz="1600" b="1" i="0">
+                <a:solidFill>
                   <a:srgbClr val="15503A"/>
                 </a:solidFill>
                 <a:latin typeface="Calibri"/>
               </a:rPr>
-              <a:t>Family Fest 2026</a:t>
-            </a:r>
-          </a:p>
-        </p:txBody>
-      </p:sp>
-      <p:sp>
-        <p:nvSpPr>
-          <p:cNvPr id="7" name="TextBox 6"/>
+              <a:t>mlr-app-omega.vercel.app</a:t>
+            </a:r>
+          </a:p>
+        </p:txBody>
+      </p:sp>
+      <p:sp>
+        <p:nvSpPr>
+          <p:cNvPr id="11" name="Rounded Rectangle 10"/>
+          <p:cNvSpPr/>
+          <p:nvPr/>
+        </p:nvSpPr>
+        <p:spPr>
+          <a:xfrm>
+            <a:off x="365760" y="6510528"/>
+            <a:ext cx="11521440" cy="63500"/>
+          </a:xfrm>
+          <a:prstGeom prst="roundRect">
+            <a:avLst>
+              <a:gd name="adj" fmla="val 6000"/>
+            </a:avLst>
+          </a:prstGeom>
+          <a:solidFill>
+            <a:srgbClr val="E5E4DA"/>
+          </a:solidFill>
+          <a:ln>
+            <a:noFill/>
+          </a:ln>
+          <a:effectLst/>
+        </p:spPr>
+        <p:style>
+          <a:lnRef idx="1">
+            <a:schemeClr val="accent1"/>
+          </a:lnRef>
+          <a:fillRef idx="3">
+            <a:schemeClr val="accent1"/>
+          </a:fillRef>
+          <a:effectRef idx="2">
+            <a:schemeClr val="accent1"/>
+          </a:effectRef>
+          <a:fontRef idx="minor">
+            <a:schemeClr val="lt1"/>
+          </a:fontRef>
+        </p:style>
+        <p:txBody>
+          <a:bodyPr rtlCol="0" anchor="ctr"/>
+          <a:lstStyle/>
+          <a:p>
+            <a:pPr algn="ctr"/>
+          </a:p>
+        </p:txBody>
+      </p:sp>
+      <p:sp>
+        <p:nvSpPr>
+          <p:cNvPr id="12" name="Rounded Rectangle 11"/>
+          <p:cNvSpPr/>
+          <p:nvPr/>
+        </p:nvSpPr>
+        <p:spPr>
+          <a:xfrm>
+            <a:off x="365760" y="6510528"/>
+            <a:ext cx="11521440" cy="63500"/>
+          </a:xfrm>
+          <a:prstGeom prst="roundRect">
+            <a:avLst>
+              <a:gd name="adj" fmla="val 6000"/>
+            </a:avLst>
+          </a:prstGeom>
+          <a:solidFill>
+            <a:srgbClr val="C2410C"/>
+          </a:solidFill>
+          <a:ln>
+            <a:noFill/>
+          </a:ln>
+          <a:effectLst/>
+        </p:spPr>
+        <p:style>
+          <a:lnRef idx="1">
+            <a:schemeClr val="accent1"/>
+          </a:lnRef>
+          <a:fillRef idx="3">
+            <a:schemeClr val="accent1"/>
+          </a:fillRef>
+          <a:effectRef idx="2">
+            <a:schemeClr val="accent1"/>
+          </a:effectRef>
+          <a:fontRef idx="minor">
+            <a:schemeClr val="lt1"/>
+          </a:fontRef>
+        </p:style>
+        <p:txBody>
+          <a:bodyPr rtlCol="0" anchor="ctr"/>
+          <a:lstStyle/>
+          <a:p>
+            <a:pPr algn="ctr"/>
+          </a:p>
+        </p:txBody>
+      </p:sp>
+      <p:sp>
+        <p:nvSpPr>
+          <p:cNvPr id="13" name="TextBox 12"/>
           <p:cNvSpPr txBox="1"/>
           <p:nvPr/>
         </p:nvSpPr>
         <p:spPr>
           <a:xfrm>
-            <a:off x="685800" y="1874520"/>
-            <a:ext cx="5029200" cy="548640"/>
+            <a:off x="365760" y="6163056"/>
+            <a:ext cx="11430000" cy="292608"/>
           </a:xfrm>
           <a:prstGeom prst="rect">
             <a:avLst/>
@@ -13176,40 +13293,63 @@
               </a:spcAft>
             </a:pPr>
             <a:r>
-              <a:rPr sz="1300" b="0" i="0">
-                <a:solidFill>
-                  <a:srgbClr val="14241C"/>
-                </a:solidFill>
-                <a:latin typeface="Calibri"/>
-              </a:rPr>
-              <a:t>July 27–31 (Mon–Fri) · “Ye Olde Family Feste” · $100/adult</a:t>
-            </a:r>
-          </a:p>
-        </p:txBody>
-      </p:sp>
-      <p:sp>
-        <p:nvSpPr>
-          <p:cNvPr id="8" name="Rounded Rectangle 7"/>
+              <a:rPr sz="1100" b="1" i="0">
+                <a:solidFill>
+                  <a:srgbClr val="6B7068"/>
+                </a:solidFill>
+                <a:latin typeface="Calibri"/>
+              </a:rPr>
+              <a:t>NEXT  ›  </a:t>
+            </a:r>
+            <a:r>
+              <a:rPr sz="1100" b="0" i="1">
+                <a:solidFill>
+                  <a:srgbClr val="6B7068"/>
+                </a:solidFill>
+                <a:latin typeface="Calibri"/>
+              </a:rPr>
+              <a:t>Quick facts (for Q&amp;A)</a:t>
+            </a:r>
+          </a:p>
+        </p:txBody>
+      </p:sp>
+    </p:spTree>
+  </p:cSld>
+  <p:clrMapOvr>
+    <a:masterClrMapping/>
+  </p:clrMapOvr>
+</p:sld>
+</file>
+
+<file path=ppt/slides/slide19.xml><?xml version="1.0" encoding="utf-8"?>
+<p:sld xmlns:a="http://schemas.openxmlformats.org/drawingml/2006/main" xmlns:p="http://schemas.openxmlformats.org/presentationml/2006/main" xmlns:r="http://schemas.openxmlformats.org/officeDocument/2006/relationships">
+  <p:cSld>
+    <p:spTree>
+      <p:nvGrpSpPr>
+        <p:cNvPr id="1" name=""/>
+        <p:cNvGrpSpPr/>
+        <p:nvPr/>
+      </p:nvGrpSpPr>
+      <p:grpSpPr/>
+      <p:sp>
+        <p:nvSpPr>
+          <p:cNvPr id="2" name="Rectangle 1"/>
           <p:cNvSpPr/>
           <p:nvPr/>
         </p:nvSpPr>
         <p:spPr>
           <a:xfrm>
-            <a:off x="457200" y="2596896"/>
-            <a:ext cx="5486400" cy="1078992"/>
-          </a:xfrm>
-          <a:prstGeom prst="roundRect">
-            <a:avLst>
-              <a:gd name="adj" fmla="val 6000"/>
-            </a:avLst>
+            <a:off x="0" y="0"/>
+            <a:ext cx="12191695" cy="6858000"/>
+          </a:xfrm>
+          <a:prstGeom prst="rect">
+            <a:avLst/>
           </a:prstGeom>
           <a:solidFill>
-            <a:srgbClr val="FFFFFF"/>
+            <a:srgbClr val="F6F6F1"/>
           </a:solidFill>
-          <a:ln w="12700">
-            <a:solidFill>
-              <a:srgbClr val="E5E4DA"/>
-            </a:solidFill>
+          <a:ln>
+            <a:noFill/>
           </a:ln>
           <a:effectLst/>
         </p:spPr>
@@ -13237,14 +13377,58 @@
       </p:sp>
       <p:sp>
         <p:nvSpPr>
-          <p:cNvPr id="9" name="TextBox 8"/>
+          <p:cNvPr id="3" name="Rectangle 2"/>
+          <p:cNvSpPr/>
+          <p:nvPr/>
+        </p:nvSpPr>
+        <p:spPr>
+          <a:xfrm>
+            <a:off x="0" y="0"/>
+            <a:ext cx="12191695" cy="1078992"/>
+          </a:xfrm>
+          <a:prstGeom prst="rect">
+            <a:avLst/>
+          </a:prstGeom>
+          <a:solidFill>
+            <a:srgbClr val="0C4029"/>
+          </a:solidFill>
+          <a:ln>
+            <a:noFill/>
+          </a:ln>
+          <a:effectLst/>
+        </p:spPr>
+        <p:style>
+          <a:lnRef idx="1">
+            <a:schemeClr val="accent1"/>
+          </a:lnRef>
+          <a:fillRef idx="3">
+            <a:schemeClr val="accent1"/>
+          </a:fillRef>
+          <a:effectRef idx="2">
+            <a:schemeClr val="accent1"/>
+          </a:effectRef>
+          <a:fontRef idx="minor">
+            <a:schemeClr val="lt1"/>
+          </a:fontRef>
+        </p:style>
+        <p:txBody>
+          <a:bodyPr rtlCol="0" anchor="ctr"/>
+          <a:lstStyle/>
+          <a:p>
+            <a:pPr algn="ctr"/>
+          </a:p>
+        </p:txBody>
+      </p:sp>
+      <p:sp>
+        <p:nvSpPr>
+          <p:cNvPr id="4" name="TextBox 3"/>
           <p:cNvSpPr txBox="1"/>
           <p:nvPr/>
         </p:nvSpPr>
         <p:spPr>
           <a:xfrm>
-            <a:off x="685800" y="2706624"/>
-            <a:ext cx="5029200" cy="365760"/>
+            <a:off x="457200" y="146304"/>
+            <a:ext cx="10972800" cy="786384"/>
           </a:xfrm>
           <a:prstGeom prst="rect">
             <a:avLst/>
@@ -13252,7 +13436,7 @@
           <a:noFill/>
         </p:spPr>
         <p:txBody>
-          <a:bodyPr wrap="square" anchor="t" lIns="25400" rIns="25400" tIns="12700" bIns="12700">
+          <a:bodyPr wrap="square" anchor="ctr" lIns="25400" rIns="25400" tIns="12700" bIns="12700">
             <a:spAutoFit/>
           </a:bodyPr>
           <a:lstStyle/>
@@ -13269,27 +13453,75 @@
               </a:spcAft>
             </a:pPr>
             <a:r>
-              <a:rPr sz="1600" b="1" i="0">
-                <a:solidFill>
-                  <a:srgbClr val="15503A"/>
-                </a:solidFill>
-                <a:latin typeface="Calibri"/>
-              </a:rPr>
-              <a:t>Where</a:t>
-            </a:r>
-          </a:p>
-        </p:txBody>
-      </p:sp>
-      <p:sp>
-        <p:nvSpPr>
-          <p:cNvPr id="10" name="TextBox 9"/>
+              <a:rPr sz="2700" b="1" i="0">
+                <a:solidFill>
+                  <a:srgbClr val="FFFFFF"/>
+                </a:solidFill>
+                <a:latin typeface="Calibri"/>
+              </a:rPr>
+              <a:t>Quick facts  ·  for live Q&amp;A</a:t>
+            </a:r>
+          </a:p>
+        </p:txBody>
+      </p:sp>
+      <p:sp>
+        <p:nvSpPr>
+          <p:cNvPr id="5" name="Rounded Rectangle 4"/>
+          <p:cNvSpPr/>
+          <p:nvPr/>
+        </p:nvSpPr>
+        <p:spPr>
+          <a:xfrm>
+            <a:off x="457200" y="1371600"/>
+            <a:ext cx="5486400" cy="1078992"/>
+          </a:xfrm>
+          <a:prstGeom prst="roundRect">
+            <a:avLst>
+              <a:gd name="adj" fmla="val 6000"/>
+            </a:avLst>
+          </a:prstGeom>
+          <a:solidFill>
+            <a:srgbClr val="FFFFFF"/>
+          </a:solidFill>
+          <a:ln w="12700">
+            <a:solidFill>
+              <a:srgbClr val="E5E4DA"/>
+            </a:solidFill>
+          </a:ln>
+          <a:effectLst/>
+        </p:spPr>
+        <p:style>
+          <a:lnRef idx="1">
+            <a:schemeClr val="accent1"/>
+          </a:lnRef>
+          <a:fillRef idx="3">
+            <a:schemeClr val="accent1"/>
+          </a:fillRef>
+          <a:effectRef idx="2">
+            <a:schemeClr val="accent1"/>
+          </a:effectRef>
+          <a:fontRef idx="minor">
+            <a:schemeClr val="lt1"/>
+          </a:fontRef>
+        </p:style>
+        <p:txBody>
+          <a:bodyPr rtlCol="0" anchor="ctr"/>
+          <a:lstStyle/>
+          <a:p>
+            <a:pPr algn="ctr"/>
+          </a:p>
+        </p:txBody>
+      </p:sp>
+      <p:sp>
+        <p:nvSpPr>
+          <p:cNvPr id="6" name="TextBox 5"/>
           <p:cNvSpPr txBox="1"/>
           <p:nvPr/>
         </p:nvSpPr>
         <p:spPr>
           <a:xfrm>
-            <a:off x="685800" y="3099816"/>
-            <a:ext cx="5029200" cy="548640"/>
+            <a:off x="685800" y="1481328"/>
+            <a:ext cx="5029200" cy="365760"/>
           </a:xfrm>
           <a:prstGeom prst="rect">
             <a:avLst/>
@@ -13314,75 +13546,27 @@
               </a:spcAft>
             </a:pPr>
             <a:r>
-              <a:rPr sz="1300" b="0" i="0">
-                <a:solidFill>
-                  <a:srgbClr val="14241C"/>
-                </a:solidFill>
-                <a:latin typeface="Calibri"/>
-              </a:rPr>
-              <a:t>Muskellunge Lake Resort, Tomahawk WI · Hwy 8, in the family since 1959</a:t>
-            </a:r>
-          </a:p>
-        </p:txBody>
-      </p:sp>
-      <p:sp>
-        <p:nvSpPr>
-          <p:cNvPr id="11" name="Rounded Rectangle 10"/>
-          <p:cNvSpPr/>
-          <p:nvPr/>
-        </p:nvSpPr>
-        <p:spPr>
-          <a:xfrm>
-            <a:off x="457200" y="3822192"/>
-            <a:ext cx="5486400" cy="1078992"/>
-          </a:xfrm>
-          <a:prstGeom prst="roundRect">
-            <a:avLst>
-              <a:gd name="adj" fmla="val 6000"/>
-            </a:avLst>
-          </a:prstGeom>
-          <a:solidFill>
-            <a:srgbClr val="FFFFFF"/>
-          </a:solidFill>
-          <a:ln w="12700">
-            <a:solidFill>
-              <a:srgbClr val="E5E4DA"/>
-            </a:solidFill>
-          </a:ln>
-          <a:effectLst/>
-        </p:spPr>
-        <p:style>
-          <a:lnRef idx="1">
-            <a:schemeClr val="accent1"/>
-          </a:lnRef>
-          <a:fillRef idx="3">
-            <a:schemeClr val="accent1"/>
-          </a:fillRef>
-          <a:effectRef idx="2">
-            <a:schemeClr val="accent1"/>
-          </a:effectRef>
-          <a:fontRef idx="minor">
-            <a:schemeClr val="lt1"/>
-          </a:fontRef>
-        </p:style>
-        <p:txBody>
-          <a:bodyPr rtlCol="0" anchor="ctr"/>
-          <a:lstStyle/>
-          <a:p>
-            <a:pPr algn="ctr"/>
-          </a:p>
-        </p:txBody>
-      </p:sp>
-      <p:sp>
-        <p:nvSpPr>
-          <p:cNvPr id="12" name="TextBox 11"/>
+              <a:rPr sz="1600" b="1" i="0">
+                <a:solidFill>
+                  <a:srgbClr val="15503A"/>
+                </a:solidFill>
+                <a:latin typeface="Calibri"/>
+              </a:rPr>
+              <a:t>Family Fest 2026</a:t>
+            </a:r>
+          </a:p>
+        </p:txBody>
+      </p:sp>
+      <p:sp>
+        <p:nvSpPr>
+          <p:cNvPr id="7" name="TextBox 6"/>
           <p:cNvSpPr txBox="1"/>
           <p:nvPr/>
         </p:nvSpPr>
         <p:spPr>
           <a:xfrm>
-            <a:off x="685800" y="3931920"/>
-            <a:ext cx="5029200" cy="365760"/>
+            <a:off x="685800" y="1874520"/>
+            <a:ext cx="5029200" cy="548640"/>
           </a:xfrm>
           <a:prstGeom prst="rect">
             <a:avLst/>
@@ -13407,27 +13591,75 @@
               </a:spcAft>
             </a:pPr>
             <a:r>
-              <a:rPr sz="1600" b="1" i="0">
-                <a:solidFill>
-                  <a:srgbClr val="15503A"/>
-                </a:solidFill>
-                <a:latin typeface="Calibri"/>
-              </a:rPr>
-              <a:t>Sign-in</a:t>
-            </a:r>
-          </a:p>
-        </p:txBody>
-      </p:sp>
-      <p:sp>
-        <p:nvSpPr>
-          <p:cNvPr id="13" name="TextBox 12"/>
+              <a:rPr sz="1300" b="0" i="0">
+                <a:solidFill>
+                  <a:srgbClr val="14241C"/>
+                </a:solidFill>
+                <a:latin typeface="Calibri"/>
+              </a:rPr>
+              <a:t>July 27–31 (Mon–Fri) · “Ye Olde Family Feste” · $100/adult</a:t>
+            </a:r>
+          </a:p>
+        </p:txBody>
+      </p:sp>
+      <p:sp>
+        <p:nvSpPr>
+          <p:cNvPr id="8" name="Rounded Rectangle 7"/>
+          <p:cNvSpPr/>
+          <p:nvPr/>
+        </p:nvSpPr>
+        <p:spPr>
+          <a:xfrm>
+            <a:off x="457200" y="2596896"/>
+            <a:ext cx="5486400" cy="1078992"/>
+          </a:xfrm>
+          <a:prstGeom prst="roundRect">
+            <a:avLst>
+              <a:gd name="adj" fmla="val 6000"/>
+            </a:avLst>
+          </a:prstGeom>
+          <a:solidFill>
+            <a:srgbClr val="FFFFFF"/>
+          </a:solidFill>
+          <a:ln w="12700">
+            <a:solidFill>
+              <a:srgbClr val="E5E4DA"/>
+            </a:solidFill>
+          </a:ln>
+          <a:effectLst/>
+        </p:spPr>
+        <p:style>
+          <a:lnRef idx="1">
+            <a:schemeClr val="accent1"/>
+          </a:lnRef>
+          <a:fillRef idx="3">
+            <a:schemeClr val="accent1"/>
+          </a:fillRef>
+          <a:effectRef idx="2">
+            <a:schemeClr val="accent1"/>
+          </a:effectRef>
+          <a:fontRef idx="minor">
+            <a:schemeClr val="lt1"/>
+          </a:fontRef>
+        </p:style>
+        <p:txBody>
+          <a:bodyPr rtlCol="0" anchor="ctr"/>
+          <a:lstStyle/>
+          <a:p>
+            <a:pPr algn="ctr"/>
+          </a:p>
+        </p:txBody>
+      </p:sp>
+      <p:sp>
+        <p:nvSpPr>
+          <p:cNvPr id="9" name="TextBox 8"/>
           <p:cNvSpPr txBox="1"/>
           <p:nvPr/>
         </p:nvSpPr>
         <p:spPr>
           <a:xfrm>
-            <a:off x="685800" y="4325112"/>
-            <a:ext cx="5029200" cy="548640"/>
+            <a:off x="685800" y="2706624"/>
+            <a:ext cx="5029200" cy="365760"/>
           </a:xfrm>
           <a:prstGeom prst="rect">
             <a:avLst/>
@@ -13452,13 +13684,196 @@
               </a:spcAft>
             </a:pPr>
             <a:r>
+              <a:rPr sz="1600" b="1" i="0">
+                <a:solidFill>
+                  <a:srgbClr val="15503A"/>
+                </a:solidFill>
+                <a:latin typeface="Calibri"/>
+              </a:rPr>
+              <a:t>Where</a:t>
+            </a:r>
+          </a:p>
+        </p:txBody>
+      </p:sp>
+      <p:sp>
+        <p:nvSpPr>
+          <p:cNvPr id="10" name="TextBox 9"/>
+          <p:cNvSpPr txBox="1"/>
+          <p:nvPr/>
+        </p:nvSpPr>
+        <p:spPr>
+          <a:xfrm>
+            <a:off x="685800" y="3099816"/>
+            <a:ext cx="5029200" cy="548640"/>
+          </a:xfrm>
+          <a:prstGeom prst="rect">
+            <a:avLst/>
+          </a:prstGeom>
+          <a:noFill/>
+        </p:spPr>
+        <p:txBody>
+          <a:bodyPr wrap="square" anchor="t" lIns="25400" rIns="25400" tIns="12700" bIns="12700">
+            <a:spAutoFit/>
+          </a:bodyPr>
+          <a:lstStyle/>
+          <a:p>
+            <a:pPr algn="l">
+              <a:lnSpc>
+                <a:spcPct val="100000"/>
+              </a:lnSpc>
+              <a:spcBef>
+                <a:spcPts val="0"/>
+              </a:spcBef>
+              <a:spcAft>
+                <a:spcPts val="400"/>
+              </a:spcAft>
+            </a:pPr>
+            <a:r>
               <a:rPr sz="1300" b="0" i="0">
                 <a:solidFill>
                   <a:srgbClr val="14241C"/>
                 </a:solidFill>
                 <a:latin typeface="Calibri"/>
               </a:rPr>
-              <a:t>Email a 6-digit code — no password. Browsing needs no account.</a:t>
+              <a:t>Muskellunge Lake Resort, Tomahawk WI · Hwy 8, in the family since 1959</a:t>
+            </a:r>
+          </a:p>
+        </p:txBody>
+      </p:sp>
+      <p:sp>
+        <p:nvSpPr>
+          <p:cNvPr id="11" name="Rounded Rectangle 10"/>
+          <p:cNvSpPr/>
+          <p:nvPr/>
+        </p:nvSpPr>
+        <p:spPr>
+          <a:xfrm>
+            <a:off x="457200" y="3822192"/>
+            <a:ext cx="5486400" cy="1078992"/>
+          </a:xfrm>
+          <a:prstGeom prst="roundRect">
+            <a:avLst>
+              <a:gd name="adj" fmla="val 6000"/>
+            </a:avLst>
+          </a:prstGeom>
+          <a:solidFill>
+            <a:srgbClr val="FFFFFF"/>
+          </a:solidFill>
+          <a:ln w="12700">
+            <a:solidFill>
+              <a:srgbClr val="E5E4DA"/>
+            </a:solidFill>
+          </a:ln>
+          <a:effectLst/>
+        </p:spPr>
+        <p:style>
+          <a:lnRef idx="1">
+            <a:schemeClr val="accent1"/>
+          </a:lnRef>
+          <a:fillRef idx="3">
+            <a:schemeClr val="accent1"/>
+          </a:fillRef>
+          <a:effectRef idx="2">
+            <a:schemeClr val="accent1"/>
+          </a:effectRef>
+          <a:fontRef idx="minor">
+            <a:schemeClr val="lt1"/>
+          </a:fontRef>
+        </p:style>
+        <p:txBody>
+          <a:bodyPr rtlCol="0" anchor="ctr"/>
+          <a:lstStyle/>
+          <a:p>
+            <a:pPr algn="ctr"/>
+          </a:p>
+        </p:txBody>
+      </p:sp>
+      <p:sp>
+        <p:nvSpPr>
+          <p:cNvPr id="12" name="TextBox 11"/>
+          <p:cNvSpPr txBox="1"/>
+          <p:nvPr/>
+        </p:nvSpPr>
+        <p:spPr>
+          <a:xfrm>
+            <a:off x="685800" y="3931920"/>
+            <a:ext cx="5029200" cy="365760"/>
+          </a:xfrm>
+          <a:prstGeom prst="rect">
+            <a:avLst/>
+          </a:prstGeom>
+          <a:noFill/>
+        </p:spPr>
+        <p:txBody>
+          <a:bodyPr wrap="square" anchor="t" lIns="25400" rIns="25400" tIns="12700" bIns="12700">
+            <a:spAutoFit/>
+          </a:bodyPr>
+          <a:lstStyle/>
+          <a:p>
+            <a:pPr algn="l">
+              <a:lnSpc>
+                <a:spcPct val="100000"/>
+              </a:lnSpc>
+              <a:spcBef>
+                <a:spcPts val="0"/>
+              </a:spcBef>
+              <a:spcAft>
+                <a:spcPts val="400"/>
+              </a:spcAft>
+            </a:pPr>
+            <a:r>
+              <a:rPr sz="1600" b="1" i="0">
+                <a:solidFill>
+                  <a:srgbClr val="15503A"/>
+                </a:solidFill>
+                <a:latin typeface="Calibri"/>
+              </a:rPr>
+              <a:t>Get it / sign in</a:t>
+            </a:r>
+          </a:p>
+        </p:txBody>
+      </p:sp>
+      <p:sp>
+        <p:nvSpPr>
+          <p:cNvPr id="13" name="TextBox 12"/>
+          <p:cNvSpPr txBox="1"/>
+          <p:nvPr/>
+        </p:nvSpPr>
+        <p:spPr>
+          <a:xfrm>
+            <a:off x="685800" y="4325112"/>
+            <a:ext cx="5029200" cy="548640"/>
+          </a:xfrm>
+          <a:prstGeom prst="rect">
+            <a:avLst/>
+          </a:prstGeom>
+          <a:noFill/>
+        </p:spPr>
+        <p:txBody>
+          <a:bodyPr wrap="square" anchor="t" lIns="25400" rIns="25400" tIns="12700" bIns="12700">
+            <a:spAutoFit/>
+          </a:bodyPr>
+          <a:lstStyle/>
+          <a:p>
+            <a:pPr algn="l">
+              <a:lnSpc>
+                <a:spcPct val="100000"/>
+              </a:lnSpc>
+              <a:spcBef>
+                <a:spcPts val="0"/>
+              </a:spcBef>
+              <a:spcAft>
+                <a:spcPts val="400"/>
+              </a:spcAft>
+            </a:pPr>
+            <a:r>
+              <a:rPr sz="1300" b="0" i="0">
+                <a:solidFill>
+                  <a:srgbClr val="14241C"/>
+                </a:solidFill>
+                <a:latin typeface="Calibri"/>
+              </a:rPr>
+              <a:t>mlr-app-omega.vercel.app · email a 6-digit code, no password · browsing needs no account</a:t>
             </a:r>
           </a:p>
         </p:txBody>

</xml_diff>

<commit_message>
Correct deck content: remove fabricated facts, fix the "why"
Replace invented/placeholder content with what the app actually contains:
- Reframe the "why it exists" around the real problem — scattered
  communication and everyone assuming someone else is handling it, so no
  one's sure what's happening — instead of a made-up "dozen Google forms."
- Drop fabricated quick-facts (resort WiFi password, front-desk phone/hours)
  and the invented "signature nights" itinerary; the daily schedule is
  genuinely still TBD.
- Keep only what's real in the data (dates, $100/adult, each night's chef,
  committee leads, scavenger hunt) and add an honest "what's set vs still
  TBD" card.
- Stop naming invented sample posts; tie the Feed to the communication point.

Co-Authored-By: Claude Opus 4.8 <noreply@anthropic.com>
Claude-Session: https://claude.ai/code/session_01GPsmd6YXd57iQdi83SeC2j
</commit_message>
<xml_diff>
--- a/presentation/MLR-App-Presentation.pptx
+++ b/presentation/MLR-App-Presentation.pptx
@@ -1290,7 +1290,7 @@
           <a:lstStyle/>
           <a:p>
             <a:r>
-              <a:t>Keep this short — it's the 'why should I care.' Land the 'one place instead of ten' idea and move on.</a:t>
+              <a:t>The real 'why': communication is scattered and everyone assumes someone else is handling it, so nobody's sure what's happening. The app is the one place that makes the plan — and the gaps — visible. Land that, then move on.</a:t>
             </a:r>
           </a:p>
         </p:txBody>
@@ -1570,7 +1570,7 @@
           <a:lstStyle/>
           <a:p>
             <a:r>
-              <a:t>This is the emotional core — spend the most time here. Tap into Schedule and Dinners so they see real names and times. Family Fest is wine-colored, a different look — that's on purpose.</a:t>
+              <a:t>Emotional core — spend the most time here. Be honest that a lot is still TBD; that's the point — this is where it gets decided and shared instead of lost in texts. The chefs are set; menus/times aren't yet. Family Fest is wine-colored on purpose.</a:t>
             </a:r>
           </a:p>
         </p:txBody>
@@ -1710,7 +1710,7 @@
           <a:lstStyle/>
           <a:p>
             <a:r>
-              <a:t>Point at a real sample post and read it aloud — makes it feel alive. This is the 'why you'll open it even when it's not Fest week' feature.</a:t>
+              <a:t>Whatever real posts are on the feed, scroll and point at one — makes it feel alive. This is the 'why you'll open it even when it's not Fest week' feature.</a:t>
             </a:r>
           </a:p>
         </p:txBody>
@@ -13527,7 +13527,7 @@
                 </a:solidFill>
                 <a:latin typeface="Calibri"/>
               </a:rPr>
-              <a:t>July 27–31 (Mon–Fri) · “Ye Olde Family Feste” · $100/adult</a:t>
+              <a:t>July 27–31 (Mon–Fri) · “Ye Olde Family Feste” · $100/adult, kids TBD</a:t>
             </a:r>
           </a:p>
         </p:txBody>
@@ -13665,7 +13665,7 @@
                 </a:solidFill>
                 <a:latin typeface="Calibri"/>
               </a:rPr>
-              <a:t>Muskellunge Lake Resort, Tomahawk WI · Hwy 8, in the family since 1959</a:t>
+              <a:t>Muskellunge Lake · 5 mi from Tomahawk on Hwy 8, WI · in the family since 1959</a:t>
             </a:r>
           </a:p>
         </p:txBody>
@@ -13941,7 +13941,7 @@
                 </a:solidFill>
                 <a:latin typeface="Calibri"/>
               </a:rPr>
-              <a:t>Venmo (preferred) or Zelle · Cathy Hofer collects · app stores nothing</a:t>
+              <a:t>Venmo (preferred) or Zelle · Cathy Hofer collects dues · app stores nothing</a:t>
             </a:r>
           </a:p>
         </p:txBody>
@@ -14034,7 +14034,7 @@
                 </a:solidFill>
                 <a:latin typeface="Calibri"/>
               </a:rPr>
-              <a:t>Signature nights</a:t>
+              <a:t>What's set vs still TBD</a:t>
             </a:r>
           </a:p>
         </p:txBody>
@@ -14079,7 +14079,7 @@
                 </a:solidFill>
                 <a:latin typeface="Calibri"/>
               </a:rPr>
-              <a:t>Mon bonfire · Wed musky tourney · Thu talent show · Fri fireworks</a:t>
+              <a:t>Set: the dates + each night's chef. Still TBD: daily times, spots, menus — they fill in on the app</a:t>
             </a:r>
           </a:p>
         </p:txBody>
@@ -14172,7 +14172,7 @@
                 </a:solidFill>
                 <a:latin typeface="Calibri"/>
               </a:rPr>
-              <a:t>Resort WiFi</a:t>
+              <a:t>Dinners</a:t>
             </a:r>
           </a:p>
         </p:txBody>
@@ -14217,7 +14217,7 @@
                 </a:solidFill>
                 <a:latin typeface="Calibri"/>
               </a:rPr>
-              <a:t>Network: MLR-Guest   ·   Password: musky2026</a:t>
+              <a:t>A chef each night — Mon Jessica · Tue Natalie &amp; Karen · Wed Lauren · Thu Rob &amp; Joe · Fri TBD</a:t>
             </a:r>
           </a:p>
         </p:txBody>
@@ -14310,7 +14310,7 @@
                 </a:solidFill>
                 <a:latin typeface="Calibri"/>
               </a:rPr>
-              <a:t>Front desk / check-in</a:t>
+              <a:t>Committees</a:t>
             </a:r>
           </a:p>
         </p:txBody>
@@ -14355,7 +14355,7 @@
                 </a:solidFill>
                 <a:latin typeface="Calibri"/>
               </a:rPr>
-              <a:t>Phone 715-555-0100 · check-in 4pm, out 11am</a:t>
+              <a:t>Meals (Lauren) · Entertainment (Keith) · Art (Jenny) · Merch (Rick) · Logistics &amp; dues (Cathy)</a:t>
             </a:r>
           </a:p>
         </p:txBody>
@@ -14448,7 +14448,7 @@
                 </a:solidFill>
                 <a:latin typeface="Calibri"/>
               </a:rPr>
-              <a:t>Need help (you)</a:t>
+              <a:t>All week</a:t>
             </a:r>
           </a:p>
         </p:txBody>
@@ -14493,7 +14493,7 @@
                 </a:solidFill>
                 <a:latin typeface="Calibri"/>
               </a:rPr>
-              <a:t>Brian Theis · 224-800-5389 · brian.theis15@gmail.com</a:t>
+              <a:t>Scavenger hunt — grab a card at the Main Lodge, finish any day</a:t>
             </a:r>
           </a:p>
         </p:txBody>
@@ -15680,7 +15680,7 @@
                 </a:solidFill>
                 <a:latin typeface="Calibri"/>
               </a:rPr>
-              <a:t>plans live in texts, group chats, emails, and a dozen Google forms. Things get lost. New people don't know where to look.</a:t>
+              <a:t>plans get passed around in scattered texts and calls — and a lot of “I figured someone else had it.” Things slip, and most of us aren't sure what's actually happening or who's in charge of what.</a:t>
             </a:r>
           </a:p>
           <a:p>
@@ -15711,7 +15711,7 @@
                 </a:solidFill>
                 <a:latin typeface="Calibri"/>
               </a:rPr>
-              <a:t>one place — schedule, who's coming, photos, who to pay, how to reach anyone, and everything Family Fest, all in your pocket.</a:t>
+              <a:t>one place everyone can open — what's planned, who's leading each part, who's coming, and what still needs hands.</a:t>
             </a:r>
           </a:p>
           <a:p>
@@ -15742,7 +15742,7 @@
                 </a:solidFill>
                 <a:latin typeface="Calibri"/>
               </a:rPr>
-              <a:t>(1) the resort, year-round — fishing, cabins, local spots.  (2) Family Fest — the one week the whole clan shows up.</a:t>
+              <a:t>(1) the resort, year-round.  (2) Family Fest — the one week the whole clan shows up.</a:t>
             </a:r>
           </a:p>
           <a:p>
@@ -15764,7 +15764,7 @@
                 </a:solidFill>
                 <a:latin typeface="Calibri"/>
               </a:rPr>
-              <a:t>It's a web app — no app store, works on any phone, tablet, or computer, and you can add it to your home screen like a real app.</a:t>
+              <a:t>It's a web app — no app store, works on any phone, and you add it to your home screen like a real app.</a:t>
             </a:r>
           </a:p>
         </p:txBody>
@@ -18317,7 +18317,7 @@
                 </a:solidFill>
                 <a:latin typeface="Calibri"/>
               </a:rPr>
-              <a:t> — swipe-away call-outs like the t-shirt vote</a:t>
+              <a:t> — swipe-away updates — news, reminders, things that need you</a:t>
             </a:r>
           </a:p>
           <a:p>
@@ -19337,7 +19337,7 @@
                 </a:solidFill>
                 <a:latin typeface="Calibri"/>
               </a:rPr>
-              <a:t>Signature nights</a:t>
+              <a:t>A dinner &amp; a chef each night</a:t>
             </a:r>
             <a:r>
               <a:rPr sz="1900" b="0" i="0">
@@ -19346,7 +19346,7 @@
                 </a:solidFill>
                 <a:latin typeface="Calibri"/>
               </a:rPr>
-              <a:t> — Mon bonfire, Wed musky tournament, Thu talent show, Fri fireworks</a:t>
+              <a:t> — Mon Jessica · Tue Natalie &amp; Karen · Wed Lauren · Thu Rob &amp; Joe · Fri TBD</a:t>
             </a:r>
           </a:p>
           <a:p>
@@ -19377,7 +19377,7 @@
                 </a:solidFill>
                 <a:latin typeface="Calibri"/>
               </a:rPr>
-              <a:t>Dinners each night</a:t>
+              <a:t>The week, day by day</a:t>
             </a:r>
             <a:r>
               <a:rPr sz="1900" b="0" i="0">
@@ -19386,7 +19386,7 @@
                 </a:solidFill>
                 <a:latin typeface="Calibri"/>
               </a:rPr>
-              <a:t> — chefs: Jessica, Natalie &amp; Karen, Lauren, Rob &amp; Joe</a:t>
+              <a:t> — a few things planned — scavenger hunt, lake day, golf — most times &amp; spots still TBD</a:t>
             </a:r>
           </a:p>
           <a:p>
@@ -19417,7 +19417,7 @@
                 </a:solidFill>
                 <a:latin typeface="Calibri"/>
               </a:rPr>
-              <a:t>All-week fun</a:t>
+              <a:t>This is where it firms up</a:t>
             </a:r>
             <a:r>
               <a:rPr sz="1900" b="0" i="0">
@@ -19426,7 +19426,7 @@
                 </a:solidFill>
                 <a:latin typeface="Calibri"/>
               </a:rPr>
-              <a:t> — scavenger hunt, lake day, golf outing, games up top</a:t>
+              <a:t> — as plans get decided, they show up here for everyone</a:t>
             </a:r>
           </a:p>
           <a:p>
@@ -21404,7 +21404,7 @@
                 </a:solidFill>
                 <a:latin typeface="Calibri"/>
               </a:rPr>
-              <a:t> — “First musky of the season,” sunset off the dock</a:t>
+              <a:t> — a photo, a catch, a sunset, a quick heads-up</a:t>
             </a:r>
           </a:p>
           <a:p>
@@ -21515,7 +21515,7 @@
                 </a:solidFill>
                 <a:latin typeface="Calibri"/>
               </a:rPr>
-              <a:t>Real examples</a:t>
+              <a:t>Everyone's in the loop</a:t>
             </a:r>
             <a:r>
               <a:rPr sz="1900" b="0" i="0">
@@ -21524,7 +21524,7 @@
                 </a:solidFill>
                 <a:latin typeface="Calibri"/>
               </a:rPr>
-              <a:t> — Grandpa's musky, Aunt Linda's countdown post</a:t>
+              <a:t> — you see what's going on — not just whoever was on the text thread</a:t>
             </a:r>
           </a:p>
         </p:txBody>

</xml_diff>

<commit_message>
Correct deck content: remove fabricated facts, fix the "why" (#211)
Replace invented/placeholder content with what the app actually contains:
- Reframe the "why it exists" around the real problem — scattered
  communication and everyone assuming someone else is handling it, so no
  one's sure what's happening — instead of a made-up "dozen Google forms."
- Drop fabricated quick-facts (resort WiFi password, front-desk phone/hours)
  and the invented "signature nights" itinerary; the daily schedule is
  genuinely still TBD.
- Keep only what's real in the data (dates, $100/adult, each night's chef,
  committee leads, scavenger hunt) and add an honest "what's set vs still
  TBD" card.
- Stop naming invented sample posts; tie the Feed to the communication point.


Claude-Session: https://claude.ai/code/session_01GPsmd6YXd57iQdi83SeC2j

Co-authored-by: Claude <noreply@anthropic.com>
</commit_message>
<xml_diff>
--- a/presentation/MLR-App-Presentation.pptx
+++ b/presentation/MLR-App-Presentation.pptx
@@ -1290,7 +1290,7 @@
           <a:lstStyle/>
           <a:p>
             <a:r>
-              <a:t>Keep this short — it's the 'why should I care.' Land the 'one place instead of ten' idea and move on.</a:t>
+              <a:t>The real 'why': communication is scattered and everyone assumes someone else is handling it, so nobody's sure what's happening. The app is the one place that makes the plan — and the gaps — visible. Land that, then move on.</a:t>
             </a:r>
           </a:p>
         </p:txBody>
@@ -1570,7 +1570,7 @@
           <a:lstStyle/>
           <a:p>
             <a:r>
-              <a:t>This is the emotional core — spend the most time here. Tap into Schedule and Dinners so they see real names and times. Family Fest is wine-colored, a different look — that's on purpose.</a:t>
+              <a:t>Emotional core — spend the most time here. Be honest that a lot is still TBD; that's the point — this is where it gets decided and shared instead of lost in texts. The chefs are set; menus/times aren't yet. Family Fest is wine-colored on purpose.</a:t>
             </a:r>
           </a:p>
         </p:txBody>
@@ -1710,7 +1710,7 @@
           <a:lstStyle/>
           <a:p>
             <a:r>
-              <a:t>Point at a real sample post and read it aloud — makes it feel alive. This is the 'why you'll open it even when it's not Fest week' feature.</a:t>
+              <a:t>Whatever real posts are on the feed, scroll and point at one — makes it feel alive. This is the 'why you'll open it even when it's not Fest week' feature.</a:t>
             </a:r>
           </a:p>
         </p:txBody>
@@ -13527,7 +13527,7 @@
                 </a:solidFill>
                 <a:latin typeface="Calibri"/>
               </a:rPr>
-              <a:t>July 27–31 (Mon–Fri) · “Ye Olde Family Feste” · $100/adult</a:t>
+              <a:t>July 27–31 (Mon–Fri) · “Ye Olde Family Feste” · $100/adult, kids TBD</a:t>
             </a:r>
           </a:p>
         </p:txBody>
@@ -13665,7 +13665,7 @@
                 </a:solidFill>
                 <a:latin typeface="Calibri"/>
               </a:rPr>
-              <a:t>Muskellunge Lake Resort, Tomahawk WI · Hwy 8, in the family since 1959</a:t>
+              <a:t>Muskellunge Lake · 5 mi from Tomahawk on Hwy 8, WI · in the family since 1959</a:t>
             </a:r>
           </a:p>
         </p:txBody>
@@ -13941,7 +13941,7 @@
                 </a:solidFill>
                 <a:latin typeface="Calibri"/>
               </a:rPr>
-              <a:t>Venmo (preferred) or Zelle · Cathy Hofer collects · app stores nothing</a:t>
+              <a:t>Venmo (preferred) or Zelle · Cathy Hofer collects dues · app stores nothing</a:t>
             </a:r>
           </a:p>
         </p:txBody>
@@ -14034,7 +14034,7 @@
                 </a:solidFill>
                 <a:latin typeface="Calibri"/>
               </a:rPr>
-              <a:t>Signature nights</a:t>
+              <a:t>What's set vs still TBD</a:t>
             </a:r>
           </a:p>
         </p:txBody>
@@ -14079,7 +14079,7 @@
                 </a:solidFill>
                 <a:latin typeface="Calibri"/>
               </a:rPr>
-              <a:t>Mon bonfire · Wed musky tourney · Thu talent show · Fri fireworks</a:t>
+              <a:t>Set: the dates + each night's chef. Still TBD: daily times, spots, menus — they fill in on the app</a:t>
             </a:r>
           </a:p>
         </p:txBody>
@@ -14172,7 +14172,7 @@
                 </a:solidFill>
                 <a:latin typeface="Calibri"/>
               </a:rPr>
-              <a:t>Resort WiFi</a:t>
+              <a:t>Dinners</a:t>
             </a:r>
           </a:p>
         </p:txBody>
@@ -14217,7 +14217,7 @@
                 </a:solidFill>
                 <a:latin typeface="Calibri"/>
               </a:rPr>
-              <a:t>Network: MLR-Guest   ·   Password: musky2026</a:t>
+              <a:t>A chef each night — Mon Jessica · Tue Natalie &amp; Karen · Wed Lauren · Thu Rob &amp; Joe · Fri TBD</a:t>
             </a:r>
           </a:p>
         </p:txBody>
@@ -14310,7 +14310,7 @@
                 </a:solidFill>
                 <a:latin typeface="Calibri"/>
               </a:rPr>
-              <a:t>Front desk / check-in</a:t>
+              <a:t>Committees</a:t>
             </a:r>
           </a:p>
         </p:txBody>
@@ -14355,7 +14355,7 @@
                 </a:solidFill>
                 <a:latin typeface="Calibri"/>
               </a:rPr>
-              <a:t>Phone 715-555-0100 · check-in 4pm, out 11am</a:t>
+              <a:t>Meals (Lauren) · Entertainment (Keith) · Art (Jenny) · Merch (Rick) · Logistics &amp; dues (Cathy)</a:t>
             </a:r>
           </a:p>
         </p:txBody>
@@ -14448,7 +14448,7 @@
                 </a:solidFill>
                 <a:latin typeface="Calibri"/>
               </a:rPr>
-              <a:t>Need help (you)</a:t>
+              <a:t>All week</a:t>
             </a:r>
           </a:p>
         </p:txBody>
@@ -14493,7 +14493,7 @@
                 </a:solidFill>
                 <a:latin typeface="Calibri"/>
               </a:rPr>
-              <a:t>Brian Theis · 224-800-5389 · brian.theis15@gmail.com</a:t>
+              <a:t>Scavenger hunt — grab a card at the Main Lodge, finish any day</a:t>
             </a:r>
           </a:p>
         </p:txBody>
@@ -15680,7 +15680,7 @@
                 </a:solidFill>
                 <a:latin typeface="Calibri"/>
               </a:rPr>
-              <a:t>plans live in texts, group chats, emails, and a dozen Google forms. Things get lost. New people don't know where to look.</a:t>
+              <a:t>plans get passed around in scattered texts and calls — and a lot of “I figured someone else had it.” Things slip, and most of us aren't sure what's actually happening or who's in charge of what.</a:t>
             </a:r>
           </a:p>
           <a:p>
@@ -15711,7 +15711,7 @@
                 </a:solidFill>
                 <a:latin typeface="Calibri"/>
               </a:rPr>
-              <a:t>one place — schedule, who's coming, photos, who to pay, how to reach anyone, and everything Family Fest, all in your pocket.</a:t>
+              <a:t>one place everyone can open — what's planned, who's leading each part, who's coming, and what still needs hands.</a:t>
             </a:r>
           </a:p>
           <a:p>
@@ -15742,7 +15742,7 @@
                 </a:solidFill>
                 <a:latin typeface="Calibri"/>
               </a:rPr>
-              <a:t>(1) the resort, year-round — fishing, cabins, local spots.  (2) Family Fest — the one week the whole clan shows up.</a:t>
+              <a:t>(1) the resort, year-round.  (2) Family Fest — the one week the whole clan shows up.</a:t>
             </a:r>
           </a:p>
           <a:p>
@@ -15764,7 +15764,7 @@
                 </a:solidFill>
                 <a:latin typeface="Calibri"/>
               </a:rPr>
-              <a:t>It's a web app — no app store, works on any phone, tablet, or computer, and you can add it to your home screen like a real app.</a:t>
+              <a:t>It's a web app — no app store, works on any phone, and you add it to your home screen like a real app.</a:t>
             </a:r>
           </a:p>
         </p:txBody>
@@ -18317,7 +18317,7 @@
                 </a:solidFill>
                 <a:latin typeface="Calibri"/>
               </a:rPr>
-              <a:t> — swipe-away call-outs like the t-shirt vote</a:t>
+              <a:t> — swipe-away updates — news, reminders, things that need you</a:t>
             </a:r>
           </a:p>
           <a:p>
@@ -19337,7 +19337,7 @@
                 </a:solidFill>
                 <a:latin typeface="Calibri"/>
               </a:rPr>
-              <a:t>Signature nights</a:t>
+              <a:t>A dinner &amp; a chef each night</a:t>
             </a:r>
             <a:r>
               <a:rPr sz="1900" b="0" i="0">
@@ -19346,7 +19346,7 @@
                 </a:solidFill>
                 <a:latin typeface="Calibri"/>
               </a:rPr>
-              <a:t> — Mon bonfire, Wed musky tournament, Thu talent show, Fri fireworks</a:t>
+              <a:t> — Mon Jessica · Tue Natalie &amp; Karen · Wed Lauren · Thu Rob &amp; Joe · Fri TBD</a:t>
             </a:r>
           </a:p>
           <a:p>
@@ -19377,7 +19377,7 @@
                 </a:solidFill>
                 <a:latin typeface="Calibri"/>
               </a:rPr>
-              <a:t>Dinners each night</a:t>
+              <a:t>The week, day by day</a:t>
             </a:r>
             <a:r>
               <a:rPr sz="1900" b="0" i="0">
@@ -19386,7 +19386,7 @@
                 </a:solidFill>
                 <a:latin typeface="Calibri"/>
               </a:rPr>
-              <a:t> — chefs: Jessica, Natalie &amp; Karen, Lauren, Rob &amp; Joe</a:t>
+              <a:t> — a few things planned — scavenger hunt, lake day, golf — most times &amp; spots still TBD</a:t>
             </a:r>
           </a:p>
           <a:p>
@@ -19417,7 +19417,7 @@
                 </a:solidFill>
                 <a:latin typeface="Calibri"/>
               </a:rPr>
-              <a:t>All-week fun</a:t>
+              <a:t>This is where it firms up</a:t>
             </a:r>
             <a:r>
               <a:rPr sz="1900" b="0" i="0">
@@ -19426,7 +19426,7 @@
                 </a:solidFill>
                 <a:latin typeface="Calibri"/>
               </a:rPr>
-              <a:t> — scavenger hunt, lake day, golf outing, games up top</a:t>
+              <a:t> — as plans get decided, they show up here for everyone</a:t>
             </a:r>
           </a:p>
           <a:p>
@@ -21404,7 +21404,7 @@
                 </a:solidFill>
                 <a:latin typeface="Calibri"/>
               </a:rPr>
-              <a:t> — “First musky of the season,” sunset off the dock</a:t>
+              <a:t> — a photo, a catch, a sunset, a quick heads-up</a:t>
             </a:r>
           </a:p>
           <a:p>
@@ -21515,7 +21515,7 @@
                 </a:solidFill>
                 <a:latin typeface="Calibri"/>
               </a:rPr>
-              <a:t>Real examples</a:t>
+              <a:t>Everyone's in the loop</a:t>
             </a:r>
             <a:r>
               <a:rPr sz="1900" b="0" i="0">
@@ -21524,7 +21524,7 @@
                 </a:solidFill>
                 <a:latin typeface="Calibri"/>
               </a:rPr>
-              <a:t> — Grandpa's musky, Aunt Linda's countdown post</a:t>
+              <a:t> — you see what's going on — not just whoever was on the text thread</a:t>
             </a:r>
           </a:p>
         </p:txBody>

</xml_diff>